<commit_message>
chore(pptx): updated slides for presentation
</commit_message>
<xml_diff>
--- a/presentacion_automatizacion_mysql_python_excel.pptx
+++ b/presentacion_automatizacion_mysql_python_excel.pptx
@@ -123,2238 +123,6 @@
     </p:ext>
   </p:extLst>
 </p:presentation>
-</file>
-
-<file path=ppt/diagrams/colors1.xml><?xml version="1.0" encoding="utf-8"?>
-<dgm:colorsDef xmlns:dgm="http://schemas.openxmlformats.org/drawingml/2006/diagram" xmlns:a="http://schemas.openxmlformats.org/drawingml/2006/main" uniqueId="urn:microsoft.com/office/officeart/2018/5/colors/Iconchunking_neutralicon_colorful1">
-  <dgm:title val=""/>
-  <dgm:desc val=""/>
-  <dgm:catLst>
-    <dgm:cat type="colorful" pri="10100"/>
-  </dgm:catLst>
-  <dgm:styleLbl name="node0">
-    <dgm:fillClrLst meth="repeat">
-      <a:schemeClr val="accent1"/>
-    </dgm:fillClrLst>
-    <dgm:linClrLst meth="repeat">
-      <a:schemeClr val="lt1"/>
-    </dgm:linClrLst>
-    <dgm:effectClrLst/>
-    <dgm:txLinClrLst/>
-    <dgm:txFillClrLst/>
-    <dgm:txEffectClrLst/>
-  </dgm:styleLbl>
-  <dgm:styleLbl name="node1">
-    <dgm:fillClrLst meth="repeat">
-      <a:schemeClr val="bg1"/>
-    </dgm:fillClrLst>
-    <dgm:linClrLst meth="repeat">
-      <a:schemeClr val="lt1">
-        <a:alpha val="0"/>
-      </a:schemeClr>
-    </dgm:linClrLst>
-    <dgm:effectClrLst/>
-    <dgm:txLinClrLst/>
-    <dgm:txFillClrLst meth="repeat">
-      <a:schemeClr val="dk1"/>
-    </dgm:txFillClrLst>
-    <dgm:txEffectClrLst/>
-  </dgm:styleLbl>
-  <dgm:styleLbl name="alignNode1">
-    <dgm:fillClrLst meth="repeat">
-      <a:schemeClr val="accent2"/>
-      <a:schemeClr val="accent3"/>
-      <a:schemeClr val="accent4"/>
-      <a:schemeClr val="accent5"/>
-      <a:schemeClr val="accent6"/>
-    </dgm:fillClrLst>
-    <dgm:linClrLst meth="repeat">
-      <a:schemeClr val="accent2"/>
-      <a:schemeClr val="accent3"/>
-      <a:schemeClr val="accent4"/>
-      <a:schemeClr val="accent5"/>
-      <a:schemeClr val="accent6"/>
-    </dgm:linClrLst>
-    <dgm:effectClrLst/>
-    <dgm:txLinClrLst/>
-    <dgm:txFillClrLst/>
-    <dgm:txEffectClrLst/>
-  </dgm:styleLbl>
-  <dgm:styleLbl name="lnNode1">
-    <dgm:fillClrLst meth="repeat">
-      <a:schemeClr val="accent2"/>
-      <a:schemeClr val="accent3"/>
-      <a:schemeClr val="accent4"/>
-      <a:schemeClr val="accent5"/>
-      <a:schemeClr val="accent6"/>
-    </dgm:fillClrLst>
-    <dgm:linClrLst meth="repeat">
-      <a:schemeClr val="lt1"/>
-    </dgm:linClrLst>
-    <dgm:effectClrLst/>
-    <dgm:txLinClrLst/>
-    <dgm:txFillClrLst/>
-    <dgm:txEffectClrLst/>
-  </dgm:styleLbl>
-  <dgm:styleLbl name="vennNode1">
-    <dgm:fillClrLst meth="repeat">
-      <a:schemeClr val="accent2">
-        <a:alpha val="50000"/>
-      </a:schemeClr>
-      <a:schemeClr val="accent3">
-        <a:alpha val="50000"/>
-      </a:schemeClr>
-      <a:schemeClr val="accent4">
-        <a:alpha val="50000"/>
-      </a:schemeClr>
-      <a:schemeClr val="accent5">
-        <a:alpha val="50000"/>
-      </a:schemeClr>
-      <a:schemeClr val="accent6">
-        <a:alpha val="50000"/>
-      </a:schemeClr>
-    </dgm:fillClrLst>
-    <dgm:linClrLst meth="repeat">
-      <a:schemeClr val="lt1"/>
-    </dgm:linClrLst>
-    <dgm:effectClrLst/>
-    <dgm:txLinClrLst/>
-    <dgm:txFillClrLst/>
-    <dgm:txEffectClrLst/>
-  </dgm:styleLbl>
-  <dgm:styleLbl name="node2">
-    <dgm:fillClrLst>
-      <a:schemeClr val="accent2"/>
-    </dgm:fillClrLst>
-    <dgm:linClrLst meth="repeat">
-      <a:schemeClr val="lt1"/>
-    </dgm:linClrLst>
-    <dgm:effectClrLst/>
-    <dgm:txLinClrLst/>
-    <dgm:txFillClrLst/>
-    <dgm:txEffectClrLst/>
-  </dgm:styleLbl>
-  <dgm:styleLbl name="node3">
-    <dgm:fillClrLst>
-      <a:schemeClr val="accent3"/>
-    </dgm:fillClrLst>
-    <dgm:linClrLst meth="repeat">
-      <a:schemeClr val="lt1"/>
-    </dgm:linClrLst>
-    <dgm:effectClrLst/>
-    <dgm:txLinClrLst/>
-    <dgm:txFillClrLst/>
-    <dgm:txEffectClrLst/>
-  </dgm:styleLbl>
-  <dgm:styleLbl name="node4">
-    <dgm:fillClrLst>
-      <a:schemeClr val="accent4"/>
-    </dgm:fillClrLst>
-    <dgm:linClrLst meth="repeat">
-      <a:schemeClr val="lt1"/>
-    </dgm:linClrLst>
-    <dgm:effectClrLst/>
-    <dgm:txLinClrLst/>
-    <dgm:txFillClrLst/>
-    <dgm:txEffectClrLst/>
-  </dgm:styleLbl>
-  <dgm:styleLbl name="fgImgPlace1">
-    <dgm:fillClrLst meth="repeat">
-      <a:schemeClr val="accent2">
-        <a:tint val="50000"/>
-      </a:schemeClr>
-      <a:schemeClr val="accent3">
-        <a:tint val="50000"/>
-      </a:schemeClr>
-      <a:schemeClr val="accent4">
-        <a:tint val="50000"/>
-      </a:schemeClr>
-      <a:schemeClr val="accent5">
-        <a:tint val="50000"/>
-      </a:schemeClr>
-      <a:schemeClr val="accent6">
-        <a:tint val="50000"/>
-      </a:schemeClr>
-    </dgm:fillClrLst>
-    <dgm:linClrLst meth="repeat">
-      <a:schemeClr val="lt1"/>
-    </dgm:linClrLst>
-    <dgm:effectClrLst/>
-    <dgm:txLinClrLst/>
-    <dgm:txFillClrLst meth="repeat">
-      <a:schemeClr val="lt1"/>
-    </dgm:txFillClrLst>
-    <dgm:txEffectClrLst/>
-  </dgm:styleLbl>
-  <dgm:styleLbl name="alignImgPlace1">
-    <dgm:fillClrLst>
-      <a:schemeClr val="accent1">
-        <a:tint val="50000"/>
-      </a:schemeClr>
-      <a:schemeClr val="accent2">
-        <a:tint val="20000"/>
-      </a:schemeClr>
-    </dgm:fillClrLst>
-    <dgm:linClrLst meth="repeat">
-      <a:schemeClr val="lt1"/>
-    </dgm:linClrLst>
-    <dgm:effectClrLst/>
-    <dgm:txLinClrLst/>
-    <dgm:txFillClrLst meth="repeat">
-      <a:schemeClr val="lt1"/>
-    </dgm:txFillClrLst>
-    <dgm:txEffectClrLst/>
-  </dgm:styleLbl>
-  <dgm:styleLbl name="bgImgPlace1">
-    <dgm:fillClrLst>
-      <a:schemeClr val="accent1">
-        <a:tint val="50000"/>
-      </a:schemeClr>
-      <a:schemeClr val="accent2">
-        <a:tint val="20000"/>
-      </a:schemeClr>
-    </dgm:fillClrLst>
-    <dgm:linClrLst meth="repeat">
-      <a:schemeClr val="lt1"/>
-    </dgm:linClrLst>
-    <dgm:effectClrLst/>
-    <dgm:txLinClrLst/>
-    <dgm:txFillClrLst meth="repeat">
-      <a:schemeClr val="lt1"/>
-    </dgm:txFillClrLst>
-    <dgm:txEffectClrLst/>
-  </dgm:styleLbl>
-  <dgm:styleLbl name="sibTrans2D1">
-    <dgm:fillClrLst meth="repeat">
-      <a:schemeClr val="accent2"/>
-      <a:schemeClr val="accent3"/>
-      <a:schemeClr val="accent4"/>
-      <a:schemeClr val="accent5"/>
-      <a:schemeClr val="accent6"/>
-    </dgm:fillClrLst>
-    <dgm:linClrLst meth="cycle">
-      <a:schemeClr val="lt1"/>
-    </dgm:linClrLst>
-    <dgm:effectClrLst/>
-    <dgm:txLinClrLst/>
-    <dgm:txFillClrLst/>
-    <dgm:txEffectClrLst/>
-  </dgm:styleLbl>
-  <dgm:styleLbl name="fgSibTrans2D1">
-    <dgm:fillClrLst meth="repeat">
-      <a:schemeClr val="accent2"/>
-      <a:schemeClr val="accent3"/>
-      <a:schemeClr val="accent4"/>
-      <a:schemeClr val="accent5"/>
-      <a:schemeClr val="accent6"/>
-    </dgm:fillClrLst>
-    <dgm:linClrLst meth="cycle">
-      <a:schemeClr val="lt1"/>
-    </dgm:linClrLst>
-    <dgm:effectClrLst/>
-    <dgm:txLinClrLst/>
-    <dgm:txFillClrLst meth="repeat">
-      <a:schemeClr val="lt1"/>
-    </dgm:txFillClrLst>
-    <dgm:txEffectClrLst/>
-  </dgm:styleLbl>
-  <dgm:styleLbl name="bgSibTrans2D1">
-    <dgm:fillClrLst meth="repeat">
-      <a:schemeClr val="accent2"/>
-      <a:schemeClr val="accent3"/>
-      <a:schemeClr val="accent4"/>
-      <a:schemeClr val="accent5"/>
-      <a:schemeClr val="accent6"/>
-    </dgm:fillClrLst>
-    <dgm:linClrLst meth="cycle">
-      <a:schemeClr val="lt1"/>
-    </dgm:linClrLst>
-    <dgm:effectClrLst/>
-    <dgm:txLinClrLst/>
-    <dgm:txFillClrLst meth="repeat">
-      <a:schemeClr val="lt1"/>
-    </dgm:txFillClrLst>
-    <dgm:txEffectClrLst/>
-  </dgm:styleLbl>
-  <dgm:styleLbl name="sibTrans1D1">
-    <dgm:fillClrLst meth="repeat">
-      <a:schemeClr val="accent2"/>
-      <a:schemeClr val="accent3"/>
-      <a:schemeClr val="accent4"/>
-      <a:schemeClr val="accent5"/>
-      <a:schemeClr val="accent6"/>
-    </dgm:fillClrLst>
-    <dgm:linClrLst meth="repeat">
-      <a:schemeClr val="accent2"/>
-      <a:schemeClr val="accent3"/>
-      <a:schemeClr val="accent4"/>
-      <a:schemeClr val="accent5"/>
-      <a:schemeClr val="accent6"/>
-    </dgm:linClrLst>
-    <dgm:effectClrLst/>
-    <dgm:txLinClrLst/>
-    <dgm:txFillClrLst meth="repeat">
-      <a:schemeClr val="tx1"/>
-    </dgm:txFillClrLst>
-    <dgm:txEffectClrLst/>
-  </dgm:styleLbl>
-  <dgm:styleLbl name="callout">
-    <dgm:fillClrLst meth="repeat">
-      <a:schemeClr val="accent2"/>
-    </dgm:fillClrLst>
-    <dgm:linClrLst meth="repeat">
-      <a:schemeClr val="accent2">
-        <a:tint val="50000"/>
-      </a:schemeClr>
-    </dgm:linClrLst>
-    <dgm:effectClrLst/>
-    <dgm:txLinClrLst/>
-    <dgm:txFillClrLst meth="repeat">
-      <a:schemeClr val="tx1"/>
-    </dgm:txFillClrLst>
-    <dgm:txEffectClrLst/>
-  </dgm:styleLbl>
-  <dgm:styleLbl name="asst0">
-    <dgm:fillClrLst meth="repeat">
-      <a:schemeClr val="accent1"/>
-    </dgm:fillClrLst>
-    <dgm:linClrLst meth="repeat">
-      <a:schemeClr val="lt1"/>
-    </dgm:linClrLst>
-    <dgm:effectClrLst/>
-    <dgm:txLinClrLst/>
-    <dgm:txFillClrLst/>
-    <dgm:txEffectClrLst/>
-  </dgm:styleLbl>
-  <dgm:styleLbl name="asst1">
-    <dgm:fillClrLst meth="repeat">
-      <a:schemeClr val="accent2"/>
-    </dgm:fillClrLst>
-    <dgm:linClrLst meth="repeat">
-      <a:schemeClr val="lt1"/>
-    </dgm:linClrLst>
-    <dgm:effectClrLst/>
-    <dgm:txLinClrLst/>
-    <dgm:txFillClrLst/>
-    <dgm:txEffectClrLst/>
-  </dgm:styleLbl>
-  <dgm:styleLbl name="asst2">
-    <dgm:fillClrLst>
-      <a:schemeClr val="accent3"/>
-    </dgm:fillClrLst>
-    <dgm:linClrLst meth="repeat">
-      <a:schemeClr val="lt1"/>
-    </dgm:linClrLst>
-    <dgm:effectClrLst/>
-    <dgm:txLinClrLst/>
-    <dgm:txFillClrLst/>
-    <dgm:txEffectClrLst/>
-  </dgm:styleLbl>
-  <dgm:styleLbl name="asst3">
-    <dgm:fillClrLst>
-      <a:schemeClr val="accent4"/>
-    </dgm:fillClrLst>
-    <dgm:linClrLst meth="repeat">
-      <a:schemeClr val="lt1"/>
-    </dgm:linClrLst>
-    <dgm:effectClrLst/>
-    <dgm:txLinClrLst/>
-    <dgm:txFillClrLst/>
-    <dgm:txEffectClrLst/>
-  </dgm:styleLbl>
-  <dgm:styleLbl name="asst4">
-    <dgm:fillClrLst>
-      <a:schemeClr val="accent5"/>
-    </dgm:fillClrLst>
-    <dgm:linClrLst meth="repeat">
-      <a:schemeClr val="lt1"/>
-    </dgm:linClrLst>
-    <dgm:effectClrLst/>
-    <dgm:txLinClrLst/>
-    <dgm:txFillClrLst/>
-    <dgm:txEffectClrLst/>
-  </dgm:styleLbl>
-  <dgm:styleLbl name="parChTrans2D1">
-    <dgm:fillClrLst meth="repeat">
-      <a:schemeClr val="accent2"/>
-    </dgm:fillClrLst>
-    <dgm:linClrLst meth="repeat">
-      <a:schemeClr val="lt1"/>
-    </dgm:linClrLst>
-    <dgm:effectClrLst/>
-    <dgm:txLinClrLst/>
-    <dgm:txFillClrLst meth="repeat">
-      <a:schemeClr val="lt1"/>
-    </dgm:txFillClrLst>
-    <dgm:txEffectClrLst/>
-  </dgm:styleLbl>
-  <dgm:styleLbl name="parChTrans2D2">
-    <dgm:fillClrLst meth="repeat">
-      <a:schemeClr val="accent3"/>
-    </dgm:fillClrLst>
-    <dgm:linClrLst meth="repeat">
-      <a:schemeClr val="lt1"/>
-    </dgm:linClrLst>
-    <dgm:effectClrLst/>
-    <dgm:txLinClrLst/>
-    <dgm:txFillClrLst/>
-    <dgm:txEffectClrLst/>
-  </dgm:styleLbl>
-  <dgm:styleLbl name="parChTrans2D3">
-    <dgm:fillClrLst meth="repeat">
-      <a:schemeClr val="accent4"/>
-    </dgm:fillClrLst>
-    <dgm:linClrLst meth="repeat">
-      <a:schemeClr val="lt1"/>
-    </dgm:linClrLst>
-    <dgm:effectClrLst/>
-    <dgm:txLinClrLst/>
-    <dgm:txFillClrLst/>
-    <dgm:txEffectClrLst/>
-  </dgm:styleLbl>
-  <dgm:styleLbl name="parChTrans2D4">
-    <dgm:fillClrLst meth="repeat">
-      <a:schemeClr val="accent5"/>
-    </dgm:fillClrLst>
-    <dgm:linClrLst meth="repeat">
-      <a:schemeClr val="lt1"/>
-    </dgm:linClrLst>
-    <dgm:effectClrLst/>
-    <dgm:txLinClrLst/>
-    <dgm:txFillClrLst meth="repeat">
-      <a:schemeClr val="lt1"/>
-    </dgm:txFillClrLst>
-    <dgm:txEffectClrLst/>
-  </dgm:styleLbl>
-  <dgm:styleLbl name="parChTrans1D1">
-    <dgm:fillClrLst meth="repeat">
-      <a:schemeClr val="accent2"/>
-    </dgm:fillClrLst>
-    <dgm:linClrLst meth="repeat">
-      <a:schemeClr val="accent1"/>
-    </dgm:linClrLst>
-    <dgm:effectClrLst/>
-    <dgm:txLinClrLst/>
-    <dgm:txFillClrLst meth="repeat">
-      <a:schemeClr val="tx1"/>
-    </dgm:txFillClrLst>
-    <dgm:txEffectClrLst/>
-  </dgm:styleLbl>
-  <dgm:styleLbl name="parChTrans1D2">
-    <dgm:fillClrLst meth="repeat">
-      <a:schemeClr val="accent3">
-        <a:tint val="90000"/>
-      </a:schemeClr>
-    </dgm:fillClrLst>
-    <dgm:linClrLst meth="repeat">
-      <a:schemeClr val="accent2"/>
-    </dgm:linClrLst>
-    <dgm:effectClrLst/>
-    <dgm:txLinClrLst/>
-    <dgm:txFillClrLst meth="repeat">
-      <a:schemeClr val="tx1"/>
-    </dgm:txFillClrLst>
-    <dgm:txEffectClrLst/>
-  </dgm:styleLbl>
-  <dgm:styleLbl name="parChTrans1D3">
-    <dgm:fillClrLst meth="repeat">
-      <a:schemeClr val="accent4">
-        <a:tint val="70000"/>
-      </a:schemeClr>
-    </dgm:fillClrLst>
-    <dgm:linClrLst meth="repeat">
-      <a:schemeClr val="accent3"/>
-    </dgm:linClrLst>
-    <dgm:effectClrLst/>
-    <dgm:txLinClrLst/>
-    <dgm:txFillClrLst meth="repeat">
-      <a:schemeClr val="tx1"/>
-    </dgm:txFillClrLst>
-    <dgm:txEffectClrLst/>
-  </dgm:styleLbl>
-  <dgm:styleLbl name="parChTrans1D4">
-    <dgm:fillClrLst meth="repeat">
-      <a:schemeClr val="accent5">
-        <a:tint val="50000"/>
-      </a:schemeClr>
-    </dgm:fillClrLst>
-    <dgm:linClrLst meth="repeat">
-      <a:schemeClr val="accent4"/>
-    </dgm:linClrLst>
-    <dgm:effectClrLst/>
-    <dgm:txLinClrLst/>
-    <dgm:txFillClrLst meth="repeat">
-      <a:schemeClr val="tx1"/>
-    </dgm:txFillClrLst>
-    <dgm:txEffectClrLst/>
-  </dgm:styleLbl>
-  <dgm:styleLbl name="fgAcc1">
-    <dgm:fillClrLst meth="repeat">
-      <a:schemeClr val="lt1">
-        <a:alpha val="90000"/>
-      </a:schemeClr>
-    </dgm:fillClrLst>
-    <dgm:linClrLst meth="repeat">
-      <a:schemeClr val="accent2"/>
-      <a:schemeClr val="accent3"/>
-      <a:schemeClr val="accent4"/>
-      <a:schemeClr val="accent5"/>
-      <a:schemeClr val="accent6"/>
-    </dgm:linClrLst>
-    <dgm:effectClrLst/>
-    <dgm:txLinClrLst/>
-    <dgm:txFillClrLst meth="repeat">
-      <a:schemeClr val="dk1"/>
-    </dgm:txFillClrLst>
-    <dgm:txEffectClrLst/>
-  </dgm:styleLbl>
-  <dgm:styleLbl name="conFgAcc1">
-    <dgm:fillClrLst meth="repeat">
-      <a:schemeClr val="lt1">
-        <a:alpha val="90000"/>
-      </a:schemeClr>
-    </dgm:fillClrLst>
-    <dgm:linClrLst meth="repeat">
-      <a:schemeClr val="accent2"/>
-      <a:schemeClr val="accent3"/>
-      <a:schemeClr val="accent4"/>
-      <a:schemeClr val="accent5"/>
-      <a:schemeClr val="accent6"/>
-    </dgm:linClrLst>
-    <dgm:effectClrLst/>
-    <dgm:txLinClrLst/>
-    <dgm:txFillClrLst meth="repeat">
-      <a:schemeClr val="dk1"/>
-    </dgm:txFillClrLst>
-    <dgm:txEffectClrLst/>
-  </dgm:styleLbl>
-  <dgm:styleLbl name="alignAcc1">
-    <dgm:fillClrLst meth="repeat">
-      <a:schemeClr val="lt1">
-        <a:alpha val="90000"/>
-      </a:schemeClr>
-    </dgm:fillClrLst>
-    <dgm:linClrLst meth="repeat">
-      <a:schemeClr val="accent2"/>
-      <a:schemeClr val="accent3"/>
-      <a:schemeClr val="accent4"/>
-      <a:schemeClr val="accent5"/>
-      <a:schemeClr val="accent6"/>
-    </dgm:linClrLst>
-    <dgm:effectClrLst/>
-    <dgm:txLinClrLst/>
-    <dgm:txFillClrLst meth="repeat">
-      <a:schemeClr val="dk1"/>
-    </dgm:txFillClrLst>
-    <dgm:txEffectClrLst/>
-  </dgm:styleLbl>
-  <dgm:styleLbl name="trAlignAcc1">
-    <dgm:fillClrLst meth="repeat">
-      <a:schemeClr val="lt1">
-        <a:alpha val="40000"/>
-      </a:schemeClr>
-    </dgm:fillClrLst>
-    <dgm:linClrLst meth="repeat">
-      <a:schemeClr val="accent1"/>
-    </dgm:linClrLst>
-    <dgm:effectClrLst/>
-    <dgm:txLinClrLst/>
-    <dgm:txFillClrLst meth="repeat">
-      <a:schemeClr val="dk1"/>
-    </dgm:txFillClrLst>
-    <dgm:txEffectClrLst/>
-  </dgm:styleLbl>
-  <dgm:styleLbl name="bgAcc1">
-    <dgm:fillClrLst meth="repeat">
-      <a:schemeClr val="lt1">
-        <a:alpha val="90000"/>
-      </a:schemeClr>
-    </dgm:fillClrLst>
-    <dgm:linClrLst meth="repeat">
-      <a:schemeClr val="accent2"/>
-      <a:schemeClr val="accent3"/>
-      <a:schemeClr val="accent4"/>
-      <a:schemeClr val="accent5"/>
-      <a:schemeClr val="accent6"/>
-    </dgm:linClrLst>
-    <dgm:effectClrLst/>
-    <dgm:txLinClrLst/>
-    <dgm:txFillClrLst meth="repeat">
-      <a:schemeClr val="dk1"/>
-    </dgm:txFillClrLst>
-    <dgm:txEffectClrLst/>
-  </dgm:styleLbl>
-  <dgm:styleLbl name="solidFgAcc1">
-    <dgm:fillClrLst meth="repeat">
-      <a:schemeClr val="lt1"/>
-    </dgm:fillClrLst>
-    <dgm:linClrLst meth="repeat">
-      <a:schemeClr val="accent2"/>
-      <a:schemeClr val="accent3"/>
-      <a:schemeClr val="accent4"/>
-      <a:schemeClr val="accent5"/>
-      <a:schemeClr val="accent6"/>
-    </dgm:linClrLst>
-    <dgm:effectClrLst/>
-    <dgm:txLinClrLst/>
-    <dgm:txFillClrLst meth="repeat">
-      <a:schemeClr val="dk1"/>
-    </dgm:txFillClrLst>
-    <dgm:txEffectClrLst/>
-  </dgm:styleLbl>
-  <dgm:styleLbl name="solidAlignAcc1">
-    <dgm:fillClrLst meth="repeat">
-      <a:schemeClr val="lt1"/>
-    </dgm:fillClrLst>
-    <dgm:linClrLst meth="repeat">
-      <a:schemeClr val="accent2"/>
-      <a:schemeClr val="accent3"/>
-      <a:schemeClr val="accent4"/>
-      <a:schemeClr val="accent5"/>
-      <a:schemeClr val="accent6"/>
-    </dgm:linClrLst>
-    <dgm:effectClrLst/>
-    <dgm:txLinClrLst/>
-    <dgm:txFillClrLst meth="repeat">
-      <a:schemeClr val="dk1"/>
-    </dgm:txFillClrLst>
-    <dgm:txEffectClrLst/>
-  </dgm:styleLbl>
-  <dgm:styleLbl name="solidBgAcc1">
-    <dgm:fillClrLst meth="repeat">
-      <a:schemeClr val="lt1"/>
-    </dgm:fillClrLst>
-    <dgm:linClrLst meth="repeat">
-      <a:schemeClr val="accent2"/>
-      <a:schemeClr val="accent3"/>
-      <a:schemeClr val="accent4"/>
-      <a:schemeClr val="accent5"/>
-      <a:schemeClr val="accent6"/>
-    </dgm:linClrLst>
-    <dgm:effectClrLst/>
-    <dgm:txLinClrLst/>
-    <dgm:txFillClrLst meth="repeat">
-      <a:schemeClr val="dk1"/>
-    </dgm:txFillClrLst>
-    <dgm:txEffectClrLst/>
-  </dgm:styleLbl>
-  <dgm:styleLbl name="fgAccFollowNode1">
-    <dgm:fillClrLst meth="repeat">
-      <a:schemeClr val="accent2">
-        <a:tint val="40000"/>
-        <a:alpha val="90000"/>
-      </a:schemeClr>
-      <a:schemeClr val="accent3">
-        <a:tint val="40000"/>
-        <a:alpha val="90000"/>
-      </a:schemeClr>
-      <a:schemeClr val="accent4">
-        <a:tint val="40000"/>
-        <a:alpha val="90000"/>
-      </a:schemeClr>
-      <a:schemeClr val="accent5">
-        <a:tint val="40000"/>
-        <a:alpha val="90000"/>
-      </a:schemeClr>
-      <a:schemeClr val="accent6">
-        <a:tint val="40000"/>
-        <a:alpha val="90000"/>
-      </a:schemeClr>
-    </dgm:fillClrLst>
-    <dgm:linClrLst meth="repeat">
-      <a:schemeClr val="accent2">
-        <a:tint val="40000"/>
-        <a:alpha val="90000"/>
-      </a:schemeClr>
-      <a:schemeClr val="accent3">
-        <a:tint val="40000"/>
-        <a:alpha val="90000"/>
-      </a:schemeClr>
-      <a:schemeClr val="accent4">
-        <a:tint val="40000"/>
-        <a:alpha val="90000"/>
-      </a:schemeClr>
-      <a:schemeClr val="accent5">
-        <a:tint val="40000"/>
-        <a:alpha val="90000"/>
-      </a:schemeClr>
-      <a:schemeClr val="accent6">
-        <a:tint val="40000"/>
-        <a:alpha val="90000"/>
-      </a:schemeClr>
-    </dgm:linClrLst>
-    <dgm:effectClrLst/>
-    <dgm:txLinClrLst/>
-    <dgm:txFillClrLst meth="repeat">
-      <a:schemeClr val="dk1"/>
-    </dgm:txFillClrLst>
-    <dgm:txEffectClrLst/>
-  </dgm:styleLbl>
-  <dgm:styleLbl name="alignAccFollowNode1">
-    <dgm:fillClrLst meth="repeat">
-      <a:schemeClr val="accent2">
-        <a:tint val="40000"/>
-        <a:alpha val="90000"/>
-      </a:schemeClr>
-      <a:schemeClr val="accent3">
-        <a:tint val="40000"/>
-        <a:alpha val="90000"/>
-      </a:schemeClr>
-      <a:schemeClr val="accent4">
-        <a:tint val="40000"/>
-        <a:alpha val="90000"/>
-      </a:schemeClr>
-      <a:schemeClr val="accent5">
-        <a:tint val="40000"/>
-        <a:alpha val="90000"/>
-      </a:schemeClr>
-      <a:schemeClr val="accent6">
-        <a:tint val="40000"/>
-        <a:alpha val="90000"/>
-      </a:schemeClr>
-    </dgm:fillClrLst>
-    <dgm:linClrLst meth="repeat">
-      <a:schemeClr val="accent2">
-        <a:tint val="40000"/>
-        <a:alpha val="90000"/>
-      </a:schemeClr>
-      <a:schemeClr val="accent3">
-        <a:tint val="40000"/>
-        <a:alpha val="90000"/>
-      </a:schemeClr>
-      <a:schemeClr val="accent4">
-        <a:tint val="40000"/>
-        <a:alpha val="90000"/>
-      </a:schemeClr>
-      <a:schemeClr val="accent5">
-        <a:tint val="40000"/>
-        <a:alpha val="90000"/>
-      </a:schemeClr>
-      <a:schemeClr val="accent6">
-        <a:tint val="40000"/>
-        <a:alpha val="90000"/>
-      </a:schemeClr>
-    </dgm:linClrLst>
-    <dgm:effectClrLst/>
-    <dgm:txLinClrLst/>
-    <dgm:txFillClrLst meth="repeat">
-      <a:schemeClr val="dk1"/>
-    </dgm:txFillClrLst>
-    <dgm:txEffectClrLst/>
-  </dgm:styleLbl>
-  <dgm:styleLbl name="bgAccFollowNode1">
-    <dgm:fillClrLst meth="repeat">
-      <a:schemeClr val="accent2">
-        <a:tint val="40000"/>
-        <a:alpha val="90000"/>
-      </a:schemeClr>
-      <a:schemeClr val="accent3">
-        <a:tint val="40000"/>
-        <a:alpha val="90000"/>
-      </a:schemeClr>
-      <a:schemeClr val="accent4">
-        <a:tint val="40000"/>
-        <a:alpha val="90000"/>
-      </a:schemeClr>
-      <a:schemeClr val="accent5">
-        <a:tint val="40000"/>
-        <a:alpha val="90000"/>
-      </a:schemeClr>
-      <a:schemeClr val="accent6">
-        <a:tint val="40000"/>
-        <a:alpha val="90000"/>
-      </a:schemeClr>
-    </dgm:fillClrLst>
-    <dgm:linClrLst meth="repeat">
-      <a:schemeClr val="accent2">
-        <a:tint val="40000"/>
-        <a:alpha val="90000"/>
-      </a:schemeClr>
-      <a:schemeClr val="accent3">
-        <a:tint val="40000"/>
-        <a:alpha val="90000"/>
-      </a:schemeClr>
-      <a:schemeClr val="accent4">
-        <a:tint val="40000"/>
-        <a:alpha val="90000"/>
-      </a:schemeClr>
-      <a:schemeClr val="accent5">
-        <a:tint val="40000"/>
-        <a:alpha val="90000"/>
-      </a:schemeClr>
-      <a:schemeClr val="accent6">
-        <a:tint val="40000"/>
-        <a:alpha val="90000"/>
-      </a:schemeClr>
-    </dgm:linClrLst>
-    <dgm:effectClrLst/>
-    <dgm:txLinClrLst/>
-    <dgm:txFillClrLst meth="repeat">
-      <a:schemeClr val="dk1"/>
-    </dgm:txFillClrLst>
-    <dgm:txEffectClrLst/>
-  </dgm:styleLbl>
-  <dgm:styleLbl name="fgAcc0">
-    <dgm:fillClrLst meth="repeat">
-      <a:schemeClr val="lt1">
-        <a:alpha val="90000"/>
-      </a:schemeClr>
-    </dgm:fillClrLst>
-    <dgm:linClrLst>
-      <a:schemeClr val="accent1"/>
-    </dgm:linClrLst>
-    <dgm:effectClrLst/>
-    <dgm:txLinClrLst/>
-    <dgm:txFillClrLst meth="repeat">
-      <a:schemeClr val="dk1"/>
-    </dgm:txFillClrLst>
-    <dgm:txEffectClrLst/>
-  </dgm:styleLbl>
-  <dgm:styleLbl name="fgAcc2">
-    <dgm:fillClrLst meth="repeat">
-      <a:schemeClr val="lt1">
-        <a:alpha val="90000"/>
-      </a:schemeClr>
-    </dgm:fillClrLst>
-    <dgm:linClrLst>
-      <a:schemeClr val="accent2"/>
-    </dgm:linClrLst>
-    <dgm:effectClrLst/>
-    <dgm:txLinClrLst/>
-    <dgm:txFillClrLst meth="repeat">
-      <a:schemeClr val="dk1"/>
-    </dgm:txFillClrLst>
-    <dgm:txEffectClrLst/>
-  </dgm:styleLbl>
-  <dgm:styleLbl name="fgAcc3">
-    <dgm:fillClrLst meth="repeat">
-      <a:schemeClr val="lt1">
-        <a:alpha val="90000"/>
-      </a:schemeClr>
-    </dgm:fillClrLst>
-    <dgm:linClrLst>
-      <a:schemeClr val="accent3"/>
-    </dgm:linClrLst>
-    <dgm:effectClrLst/>
-    <dgm:txLinClrLst/>
-    <dgm:txFillClrLst meth="repeat">
-      <a:schemeClr val="dk1"/>
-    </dgm:txFillClrLst>
-    <dgm:txEffectClrLst/>
-  </dgm:styleLbl>
-  <dgm:styleLbl name="fgAcc4">
-    <dgm:fillClrLst meth="repeat">
-      <a:schemeClr val="lt1">
-        <a:alpha val="90000"/>
-      </a:schemeClr>
-    </dgm:fillClrLst>
-    <dgm:linClrLst>
-      <a:schemeClr val="accent4"/>
-    </dgm:linClrLst>
-    <dgm:effectClrLst/>
-    <dgm:txLinClrLst/>
-    <dgm:txFillClrLst meth="repeat">
-      <a:schemeClr val="dk1"/>
-    </dgm:txFillClrLst>
-    <dgm:txEffectClrLst/>
-  </dgm:styleLbl>
-  <dgm:styleLbl name="bgShp">
-    <dgm:fillClrLst meth="repeat">
-      <a:schemeClr val="accent2"/>
-      <a:schemeClr val="accent3"/>
-      <a:schemeClr val="accent4"/>
-      <a:schemeClr val="accent5"/>
-      <a:schemeClr val="accent6"/>
-    </dgm:fillClrLst>
-    <dgm:linClrLst meth="repeat">
-      <a:schemeClr val="lt1">
-        <a:alpha val="0"/>
-      </a:schemeClr>
-    </dgm:linClrLst>
-    <dgm:effectClrLst/>
-    <dgm:txLinClrLst/>
-    <dgm:txFillClrLst/>
-    <dgm:txEffectClrLst/>
-  </dgm:styleLbl>
-  <dgm:styleLbl name="dkBgShp">
-    <dgm:fillClrLst meth="repeat">
-      <a:schemeClr val="accent2">
-        <a:shade val="90000"/>
-      </a:schemeClr>
-    </dgm:fillClrLst>
-    <dgm:linClrLst meth="repeat">
-      <a:schemeClr val="dk1"/>
-    </dgm:linClrLst>
-    <dgm:effectClrLst/>
-    <dgm:txLinClrLst/>
-    <dgm:txFillClrLst meth="repeat">
-      <a:schemeClr val="lt1"/>
-    </dgm:txFillClrLst>
-    <dgm:txEffectClrLst/>
-  </dgm:styleLbl>
-  <dgm:styleLbl name="trBgShp">
-    <dgm:fillClrLst meth="repeat">
-      <a:schemeClr val="accent1">
-        <a:tint val="50000"/>
-        <a:alpha val="40000"/>
-      </a:schemeClr>
-    </dgm:fillClrLst>
-    <dgm:linClrLst meth="repeat">
-      <a:schemeClr val="accent2"/>
-    </dgm:linClrLst>
-    <dgm:effectClrLst/>
-    <dgm:txLinClrLst/>
-    <dgm:txFillClrLst meth="repeat">
-      <a:schemeClr val="lt1"/>
-    </dgm:txFillClrLst>
-    <dgm:txEffectClrLst/>
-  </dgm:styleLbl>
-  <dgm:styleLbl name="fgShp">
-    <dgm:fillClrLst meth="repeat">
-      <a:schemeClr val="accent2">
-        <a:tint val="40000"/>
-      </a:schemeClr>
-    </dgm:fillClrLst>
-    <dgm:linClrLst meth="repeat">
-      <a:schemeClr val="lt1"/>
-    </dgm:linClrLst>
-    <dgm:effectClrLst/>
-    <dgm:txLinClrLst/>
-    <dgm:txFillClrLst meth="repeat">
-      <a:schemeClr val="dk1"/>
-    </dgm:txFillClrLst>
-    <dgm:txEffectClrLst/>
-  </dgm:styleLbl>
-  <dgm:styleLbl name="revTx">
-    <dgm:fillClrLst meth="repeat">
-      <a:schemeClr val="lt1">
-        <a:alpha val="0"/>
-      </a:schemeClr>
-    </dgm:fillClrLst>
-    <dgm:linClrLst meth="repeat">
-      <a:schemeClr val="dk1">
-        <a:alpha val="0"/>
-      </a:schemeClr>
-    </dgm:linClrLst>
-    <dgm:effectClrLst/>
-    <dgm:txLinClrLst/>
-    <dgm:txFillClrLst meth="repeat">
-      <a:schemeClr val="tx1"/>
-    </dgm:txFillClrLst>
-    <dgm:txEffectClrLst/>
-  </dgm:styleLbl>
-</dgm:colorsDef>
-</file>
-
-<file path=ppt/diagrams/data1.xml><?xml version="1.0" encoding="utf-8"?>
-<dgm:dataModel xmlns:dgm="http://schemas.openxmlformats.org/drawingml/2006/diagram" xmlns:a="http://schemas.openxmlformats.org/drawingml/2006/main">
-  <dgm:ptLst>
-    <dgm:pt modelId="{34FF870C-5D9B-4878-9827-A3D8F8D3B4C3}" type="doc">
-      <dgm:prSet loTypeId="urn:microsoft.com/office/officeart/2018/5/layout/IconLeafLabelList" loCatId="icon" qsTypeId="urn:microsoft.com/office/officeart/2005/8/quickstyle/simple1" qsCatId="simple" csTypeId="urn:microsoft.com/office/officeart/2018/5/colors/Iconchunking_neutralicon_colorful1" csCatId="colorful" phldr="1"/>
-      <dgm:spPr/>
-      <dgm:t>
-        <a:bodyPr rtlCol="0"/>
-        <a:lstStyle/>
-        <a:p>
-          <a:pPr rtl="0"/>
-          <a:endParaRPr lang="en-US"/>
-        </a:p>
-      </dgm:t>
-    </dgm:pt>
-    <dgm:pt modelId="{D2FA40C6-C0ED-46A3-92CE-B081053B2BA8}" type="pres">
-      <dgm:prSet presAssocID="{34FF870C-5D9B-4878-9827-A3D8F8D3B4C3}" presName="root" presStyleCnt="0">
-        <dgm:presLayoutVars>
-          <dgm:dir/>
-          <dgm:resizeHandles val="exact"/>
-        </dgm:presLayoutVars>
-      </dgm:prSet>
-      <dgm:spPr/>
-    </dgm:pt>
-  </dgm:ptLst>
-  <dgm:cxnLst>
-    <dgm:cxn modelId="{B126511F-11FF-4EDD-85D7-D89737033340}" type="presOf" srcId="{34FF870C-5D9B-4878-9827-A3D8F8D3B4C3}" destId="{D2FA40C6-C0ED-46A3-92CE-B081053B2BA8}" srcOrd="0" destOrd="0" presId="urn:microsoft.com/office/officeart/2018/5/layout/IconLeafLabelList"/>
-  </dgm:cxnLst>
-  <dgm:bg/>
-  <dgm:whole/>
-  <dgm:extLst>
-    <a:ext uri="http://schemas.microsoft.com/office/drawing/2008/diagram">
-      <dsp:dataModelExt xmlns:dsp="http://schemas.microsoft.com/office/drawing/2008/diagram" relId="rId7" minVer="http://schemas.openxmlformats.org/drawingml/2006/diagram"/>
-    </a:ext>
-  </dgm:extLst>
-</dgm:dataModel>
-</file>
-
-<file path=ppt/diagrams/drawing1.xml><?xml version="1.0" encoding="utf-8"?>
-<dsp:drawing xmlns:dgm="http://schemas.openxmlformats.org/drawingml/2006/diagram" xmlns:dsp="http://schemas.microsoft.com/office/drawing/2008/diagram" xmlns:a="http://schemas.openxmlformats.org/drawingml/2006/main">
-  <dsp:spTree>
-    <dsp:nvGrpSpPr>
-      <dsp:cNvPr id="0" name=""/>
-      <dsp:cNvGrpSpPr/>
-    </dsp:nvGrpSpPr>
-    <dsp:grpSpPr/>
-  </dsp:spTree>
-</dsp:drawing>
-</file>
-
-<file path=ppt/diagrams/layout1.xml><?xml version="1.0" encoding="utf-8"?>
-<dgm:layoutDef xmlns:dgm="http://schemas.openxmlformats.org/drawingml/2006/diagram" xmlns:a="http://schemas.openxmlformats.org/drawingml/2006/main" uniqueId="urn:microsoft.com/office/officeart/2018/5/layout/IconLeafLabelList">
-  <dgm:title val="Icono de lista de etiquetas de hojas"/>
-  <dgm:desc val="Se usa para mostrar fragmentos no secuenciales o agrupados de información acompañados de elementos visuales relacionados. Funciona mejor con iconos o imágenes pequeñas con leyendas de texto breve."/>
-  <dgm:catLst>
-    <dgm:cat type="icon" pri="500"/>
-  </dgm:catLst>
-  <dgm:sampData useDef="1">
-    <dgm:dataModel>
-      <dgm:ptLst/>
-      <dgm:bg/>
-      <dgm:whole/>
-    </dgm:dataModel>
-  </dgm:sampData>
-  <dgm:styleData useDef="1">
-    <dgm:dataModel>
-      <dgm:ptLst/>
-      <dgm:bg/>
-      <dgm:whole/>
-    </dgm:dataModel>
-  </dgm:styleData>
-  <dgm:clrData useDef="1">
-    <dgm:dataModel>
-      <dgm:ptLst/>
-      <dgm:bg/>
-      <dgm:whole/>
-    </dgm:dataModel>
-  </dgm:clrData>
-  <dgm:layoutNode name="root">
-    <dgm:varLst>
-      <dgm:dir/>
-      <dgm:resizeHandles val="exact"/>
-    </dgm:varLst>
-    <dgm:choose name="Name0">
-      <dgm:if name="Name1" axis="self" func="var" arg="dir" op="equ" val="norm">
-        <dgm:alg type="snake">
-          <dgm:param type="grDir" val="tL"/>
-          <dgm:param type="flowDir" val="row"/>
-          <dgm:param type="contDir" val="sameDir"/>
-          <dgm:param type="off" val="ctr"/>
-          <dgm:param type="vertAlign" val="mid"/>
-          <dgm:param type="horzAlign" val="ctr"/>
-        </dgm:alg>
-      </dgm:if>
-      <dgm:else name="Name2">
-        <dgm:alg type="snake">
-          <dgm:param type="grDir" val="tR"/>
-          <dgm:param type="flowDir" val="row"/>
-          <dgm:param type="contDir" val="sameDir"/>
-          <dgm:param type="off" val="ctr"/>
-          <dgm:param type="vertAlign" val="mid"/>
-          <dgm:param type="horzAlign" val="ctr"/>
-        </dgm:alg>
-      </dgm:else>
-    </dgm:choose>
-    <dgm:shape xmlns:r="http://schemas.openxmlformats.org/officeDocument/2006/relationships" r:blip="">
-      <dgm:adjLst/>
-    </dgm:shape>
-    <dgm:presOf/>
-    <dgm:choose name="Name3">
-      <dgm:if name="Name4" axis="ch" ptType="node" func="cnt" op="lte" val="2">
-        <dgm:constrLst>
-          <dgm:constr type="h" for="ch" forName="compNode" refType="h" fact="0.4"/>
-          <dgm:constr type="w" for="ch" forName="compNode" val="100"/>
-          <dgm:constr type="w" for="ch" forName="sibTrans" refType="w" refFor="ch" refForName="compNode" fact="0.175"/>
-          <dgm:constr type="sp" refType="w" refFor="ch" refForName="compNode" op="equ" fact="0.25"/>
-          <dgm:constr type="primFontSz" for="des" ptType="node" op="equ" val="44"/>
-          <dgm:constr type="h" for="des" forName="compNode" op="equ"/>
-          <dgm:constr type="h" for="des" forName="textRect" op="equ"/>
-        </dgm:constrLst>
-      </dgm:if>
-      <dgm:if name="Name5" axis="ch" ptType="node" func="cnt" op="lte" val="3">
-        <dgm:constrLst>
-          <dgm:constr type="h" for="ch" forName="compNode" refType="h" fact="0.4"/>
-          <dgm:constr type="w" for="ch" forName="compNode" val="100"/>
-          <dgm:constr type="w" for="ch" forName="sibTrans" refType="w" refFor="ch" refForName="compNode" fact="0.175"/>
-          <dgm:constr type="sp" refType="w" refFor="ch" refForName="compNode" op="equ" fact="0.25"/>
-          <dgm:constr type="primFontSz" for="des" ptType="node" op="equ" val="40"/>
-          <dgm:constr type="h" for="des" forName="compNode" op="equ"/>
-          <dgm:constr type="h" for="des" forName="textRect" op="equ"/>
-        </dgm:constrLst>
-      </dgm:if>
-      <dgm:if name="Name6" axis="ch" ptType="node" func="cnt" op="lte" val="4">
-        <dgm:constrLst>
-          <dgm:constr type="h" for="ch" forName="compNode" refType="h" fact="0.4"/>
-          <dgm:constr type="w" for="ch" forName="compNode" refType="w"/>
-          <dgm:constr type="w" for="ch" forName="sibTrans" refType="w" refFor="ch" refForName="compNode" fact="0.175"/>
-          <dgm:constr type="sp" refType="w" refFor="ch" refForName="compNode" op="equ" fact="0.25"/>
-          <dgm:constr type="primFontSz" for="des" ptType="node" op="equ" val="32"/>
-          <dgm:constr type="h" for="des" forName="compNode" op="equ"/>
-          <dgm:constr type="h" for="des" forName="textRect" op="equ"/>
-        </dgm:constrLst>
-      </dgm:if>
-      <dgm:else name="Name7">
-        <dgm:constrLst>
-          <dgm:constr type="h" for="ch" forName="compNode" refType="h" fact="0.4"/>
-          <dgm:constr type="w" for="ch" forName="compNode" refType="w"/>
-          <dgm:constr type="w" for="ch" forName="sibTrans" refType="w" refFor="ch" refForName="compNode" fact="0.175"/>
-          <dgm:constr type="sp" refType="w" refFor="ch" refForName="compNode" op="equ" fact="0.25"/>
-          <dgm:constr type="primFontSz" for="des" ptType="node" op="equ" val="24"/>
-          <dgm:constr type="h" for="des" forName="compNode" op="equ"/>
-          <dgm:constr type="h" for="des" forName="textRect" op="equ"/>
-        </dgm:constrLst>
-      </dgm:else>
-    </dgm:choose>
-    <dgm:ruleLst>
-      <dgm:rule type="w" for="ch" forName="compNode" val="50" fact="NaN" max="NaN"/>
-    </dgm:ruleLst>
-    <dgm:forEach name="Name8" axis="ch" ptType="node">
-      <dgm:layoutNode name="compNode">
-        <dgm:alg type="composite"/>
-        <dgm:shape xmlns:r="http://schemas.openxmlformats.org/officeDocument/2006/relationships" r:blip="">
-          <dgm:adjLst/>
-        </dgm:shape>
-        <dgm:presOf axis="self"/>
-        <dgm:constrLst>
-          <dgm:constr type="w" for="ch" forName="iconBgRect" refType="w" fact="0.61"/>
-          <dgm:constr type="h" for="ch" forName="iconBgRect" refType="w" refFor="ch" refForName="iconBgRect"/>
-          <dgm:constr type="t" for="ch" forName="iconBgRect"/>
-          <dgm:constr type="ctrX" for="ch" forName="iconBgRect" refType="w" fact="0.5"/>
-          <dgm:constr type="w" for="ch" forName="iconRect" refType="w" fact="0.35"/>
-          <dgm:constr type="h" for="ch" forName="iconRect" refType="w" refFor="ch" refForName="iconRect"/>
-          <dgm:constr type="ctrX" for="ch" forName="iconRect" refType="ctrX" refFor="ch" refForName="iconBgRect"/>
-          <dgm:constr type="ctrY" for="ch" forName="iconRect" refType="ctrY" refFor="ch" refForName="iconBgRect"/>
-          <dgm:constr type="h" for="ch" forName="spaceRect" refType="w" fact="0.19"/>
-          <dgm:constr type="w" for="ch" forName="spaceRect" refType="w"/>
-          <dgm:constr type="l" for="ch" forName="spaceRect"/>
-          <dgm:constr type="t" for="ch" forName="spaceRect" refType="b" refFor="ch" refForName="iconBgRect"/>
-          <dgm:constr type="h" for="ch" forName="textRect" val="20"/>
-          <dgm:constr type="w" for="ch" forName="textRect" refType="w"/>
-          <dgm:constr type="l" for="ch" forName="textRect"/>
-          <dgm:constr type="t" for="ch" forName="textRect" refType="b" refFor="ch" refForName="spaceRect"/>
-        </dgm:constrLst>
-        <dgm:ruleLst>
-          <dgm:rule type="h" val="INF" fact="NaN" max="NaN"/>
-        </dgm:ruleLst>
-        <dgm:layoutNode name="iconBgRect" styleLbl="bgShp">
-          <dgm:alg type="sp"/>
-          <dgm:shape xmlns:r="http://schemas.openxmlformats.org/officeDocument/2006/relationships" type="round2DiagRect" r:blip="">
-            <dgm:adjLst/>
-            <dgm:extLst>
-              <a:ext uri="{B698B0E9-8C71-41B9-8309-B3DCBF30829C}">
-                <dgm1612:spPr xmlns:dgm1612="http://schemas.microsoft.com/office/drawing/2016/12/diagram">
-                  <a:prstGeom prst="round2DiagRect">
-                    <a:avLst>
-                      <a:gd name="adj1" fmla="val 29727"/>
-                      <a:gd name="adj2" fmla="val 0"/>
-                    </a:avLst>
-                  </a:prstGeom>
-                </dgm1612:spPr>
-              </a:ext>
-            </dgm:extLst>
-          </dgm:shape>
-          <dgm:presOf/>
-          <dgm:constrLst/>
-          <dgm:ruleLst/>
-        </dgm:layoutNode>
-        <dgm:layoutNode name="iconRect" styleLbl="node1">
-          <dgm:alg type="sp"/>
-          <dgm:shape xmlns:r="http://schemas.openxmlformats.org/officeDocument/2006/relationships" type="rect" r:blip="" blipPhldr="1">
-            <dgm:adjLst/>
-          </dgm:shape>
-          <dgm:presOf/>
-          <dgm:constrLst/>
-          <dgm:ruleLst/>
-        </dgm:layoutNode>
-        <dgm:layoutNode name="spaceRect">
-          <dgm:alg type="sp"/>
-          <dgm:shape xmlns:r="http://schemas.openxmlformats.org/officeDocument/2006/relationships" r:blip="">
-            <dgm:adjLst/>
-          </dgm:shape>
-          <dgm:presOf/>
-          <dgm:constrLst/>
-          <dgm:ruleLst/>
-        </dgm:layoutNode>
-        <dgm:layoutNode name="textRect" styleLbl="revTx">
-          <dgm:varLst>
-            <dgm:chMax val="1"/>
-            <dgm:chPref val="1"/>
-          </dgm:varLst>
-          <dgm:alg type="tx">
-            <dgm:param type="txAnchorVert" val="t"/>
-          </dgm:alg>
-          <dgm:shape xmlns:r="http://schemas.openxmlformats.org/officeDocument/2006/relationships" type="rect" r:blip="">
-            <dgm:adjLst/>
-          </dgm:shape>
-          <dgm:presOf axis="self" ptType="node"/>
-          <dgm:constrLst>
-            <dgm:constr type="lMarg"/>
-            <dgm:constr type="rMarg"/>
-            <dgm:constr type="tMarg"/>
-            <dgm:constr type="bMarg"/>
-          </dgm:constrLst>
-          <dgm:ruleLst>
-            <dgm:rule type="primFontSz" val="11" fact="NaN" max="NaN"/>
-            <dgm:rule type="h" val="INF" fact="NaN" max="NaN"/>
-          </dgm:ruleLst>
-        </dgm:layoutNode>
-      </dgm:layoutNode>
-      <dgm:forEach name="Name9" axis="followSib" ptType="sibTrans" cnt="1">
-        <dgm:layoutNode name="sibTrans">
-          <dgm:alg type="sp"/>
-          <dgm:shape xmlns:r="http://schemas.openxmlformats.org/officeDocument/2006/relationships" r:blip="">
-            <dgm:adjLst/>
-          </dgm:shape>
-          <dgm:presOf axis="self"/>
-          <dgm:constrLst/>
-          <dgm:ruleLst/>
-        </dgm:layoutNode>
-      </dgm:forEach>
-    </dgm:forEach>
-  </dgm:layoutNode>
-  <dgm:extLst>
-    <a:ext uri="{68A01E43-0DF5-4B5B-8FA6-DAF915123BFB}">
-      <dgm1612:lstStyle xmlns:dgm1612="http://schemas.microsoft.com/office/drawing/2016/12/diagram">
-        <a:lvl1pPr>
-          <a:lnSpc>
-            <a:spcPct val="100000"/>
-          </a:lnSpc>
-          <a:defRPr cap="all"/>
-        </a:lvl1pPr>
-      </dgm1612:lstStyle>
-    </a:ext>
-  </dgm:extLst>
-</dgm:layoutDef>
-</file>
-
-<file path=ppt/diagrams/quickStyle1.xml><?xml version="1.0" encoding="utf-8"?>
-<dgm:styleDef xmlns:dgm="http://schemas.openxmlformats.org/drawingml/2006/diagram" xmlns:a="http://schemas.openxmlformats.org/drawingml/2006/main" uniqueId="urn:microsoft.com/office/officeart/2005/8/quickstyle/simple1">
-  <dgm:title val=""/>
-  <dgm:desc val=""/>
-  <dgm:catLst>
-    <dgm:cat type="simple" pri="10100"/>
-  </dgm:catLst>
-  <dgm:scene3d>
-    <a:camera prst="orthographicFront"/>
-    <a:lightRig rig="threePt" dir="t"/>
-  </dgm:scene3d>
-  <dgm:styleLbl name="node0">
-    <dgm:scene3d>
-      <a:camera prst="orthographicFront"/>
-      <a:lightRig rig="threePt" dir="t"/>
-    </dgm:scene3d>
-    <dgm:sp3d/>
-    <dgm:txPr/>
-    <dgm:style>
-      <a:lnRef idx="2">
-        <a:scrgbClr r="0" g="0" b="0"/>
-      </a:lnRef>
-      <a:fillRef idx="1">
-        <a:scrgbClr r="0" g="0" b="0"/>
-      </a:fillRef>
-      <a:effectRef idx="0">
-        <a:scrgbClr r="0" g="0" b="0"/>
-      </a:effectRef>
-      <a:fontRef idx="minor">
-        <a:schemeClr val="lt1"/>
-      </a:fontRef>
-    </dgm:style>
-  </dgm:styleLbl>
-  <dgm:styleLbl name="lnNode1">
-    <dgm:scene3d>
-      <a:camera prst="orthographicFront"/>
-      <a:lightRig rig="threePt" dir="t"/>
-    </dgm:scene3d>
-    <dgm:sp3d/>
-    <dgm:txPr/>
-    <dgm:style>
-      <a:lnRef idx="2">
-        <a:scrgbClr r="0" g="0" b="0"/>
-      </a:lnRef>
-      <a:fillRef idx="1">
-        <a:scrgbClr r="0" g="0" b="0"/>
-      </a:fillRef>
-      <a:effectRef idx="0">
-        <a:scrgbClr r="0" g="0" b="0"/>
-      </a:effectRef>
-      <a:fontRef idx="minor">
-        <a:schemeClr val="lt1"/>
-      </a:fontRef>
-    </dgm:style>
-  </dgm:styleLbl>
-  <dgm:styleLbl name="vennNode1">
-    <dgm:scene3d>
-      <a:camera prst="orthographicFront"/>
-      <a:lightRig rig="threePt" dir="t"/>
-    </dgm:scene3d>
-    <dgm:sp3d/>
-    <dgm:txPr/>
-    <dgm:style>
-      <a:lnRef idx="2">
-        <a:scrgbClr r="0" g="0" b="0"/>
-      </a:lnRef>
-      <a:fillRef idx="1">
-        <a:scrgbClr r="0" g="0" b="0"/>
-      </a:fillRef>
-      <a:effectRef idx="0">
-        <a:scrgbClr r="0" g="0" b="0"/>
-      </a:effectRef>
-      <a:fontRef idx="minor">
-        <a:schemeClr val="tx1"/>
-      </a:fontRef>
-    </dgm:style>
-  </dgm:styleLbl>
-  <dgm:styleLbl name="alignNode1">
-    <dgm:scene3d>
-      <a:camera prst="orthographicFront"/>
-      <a:lightRig rig="threePt" dir="t"/>
-    </dgm:scene3d>
-    <dgm:sp3d/>
-    <dgm:txPr/>
-    <dgm:style>
-      <a:lnRef idx="2">
-        <a:scrgbClr r="0" g="0" b="0"/>
-      </a:lnRef>
-      <a:fillRef idx="1">
-        <a:scrgbClr r="0" g="0" b="0"/>
-      </a:fillRef>
-      <a:effectRef idx="0">
-        <a:scrgbClr r="0" g="0" b="0"/>
-      </a:effectRef>
-      <a:fontRef idx="minor">
-        <a:schemeClr val="lt1"/>
-      </a:fontRef>
-    </dgm:style>
-  </dgm:styleLbl>
-  <dgm:styleLbl name="node1">
-    <dgm:scene3d>
-      <a:camera prst="orthographicFront"/>
-      <a:lightRig rig="threePt" dir="t"/>
-    </dgm:scene3d>
-    <dgm:sp3d/>
-    <dgm:txPr/>
-    <dgm:style>
-      <a:lnRef idx="2">
-        <a:scrgbClr r="0" g="0" b="0"/>
-      </a:lnRef>
-      <a:fillRef idx="1">
-        <a:scrgbClr r="0" g="0" b="0"/>
-      </a:fillRef>
-      <a:effectRef idx="0">
-        <a:scrgbClr r="0" g="0" b="0"/>
-      </a:effectRef>
-      <a:fontRef idx="minor">
-        <a:schemeClr val="lt1"/>
-      </a:fontRef>
-    </dgm:style>
-  </dgm:styleLbl>
-  <dgm:styleLbl name="node2">
-    <dgm:scene3d>
-      <a:camera prst="orthographicFront"/>
-      <a:lightRig rig="threePt" dir="t"/>
-    </dgm:scene3d>
-    <dgm:sp3d/>
-    <dgm:txPr/>
-    <dgm:style>
-      <a:lnRef idx="2">
-        <a:scrgbClr r="0" g="0" b="0"/>
-      </a:lnRef>
-      <a:fillRef idx="1">
-        <a:scrgbClr r="0" g="0" b="0"/>
-      </a:fillRef>
-      <a:effectRef idx="0">
-        <a:scrgbClr r="0" g="0" b="0"/>
-      </a:effectRef>
-      <a:fontRef idx="minor">
-        <a:schemeClr val="lt1"/>
-      </a:fontRef>
-    </dgm:style>
-  </dgm:styleLbl>
-  <dgm:styleLbl name="node3">
-    <dgm:scene3d>
-      <a:camera prst="orthographicFront"/>
-      <a:lightRig rig="threePt" dir="t"/>
-    </dgm:scene3d>
-    <dgm:sp3d/>
-    <dgm:txPr/>
-    <dgm:style>
-      <a:lnRef idx="2">
-        <a:scrgbClr r="0" g="0" b="0"/>
-      </a:lnRef>
-      <a:fillRef idx="1">
-        <a:scrgbClr r="0" g="0" b="0"/>
-      </a:fillRef>
-      <a:effectRef idx="0">
-        <a:scrgbClr r="0" g="0" b="0"/>
-      </a:effectRef>
-      <a:fontRef idx="minor">
-        <a:schemeClr val="lt1"/>
-      </a:fontRef>
-    </dgm:style>
-  </dgm:styleLbl>
-  <dgm:styleLbl name="node4">
-    <dgm:scene3d>
-      <a:camera prst="orthographicFront"/>
-      <a:lightRig rig="threePt" dir="t"/>
-    </dgm:scene3d>
-    <dgm:sp3d/>
-    <dgm:txPr/>
-    <dgm:style>
-      <a:lnRef idx="2">
-        <a:scrgbClr r="0" g="0" b="0"/>
-      </a:lnRef>
-      <a:fillRef idx="1">
-        <a:scrgbClr r="0" g="0" b="0"/>
-      </a:fillRef>
-      <a:effectRef idx="0">
-        <a:scrgbClr r="0" g="0" b="0"/>
-      </a:effectRef>
-      <a:fontRef idx="minor">
-        <a:schemeClr val="lt1"/>
-      </a:fontRef>
-    </dgm:style>
-  </dgm:styleLbl>
-  <dgm:styleLbl name="fgImgPlace1">
-    <dgm:scene3d>
-      <a:camera prst="orthographicFront"/>
-      <a:lightRig rig="threePt" dir="t"/>
-    </dgm:scene3d>
-    <dgm:sp3d/>
-    <dgm:txPr/>
-    <dgm:style>
-      <a:lnRef idx="2">
-        <a:scrgbClr r="0" g="0" b="0"/>
-      </a:lnRef>
-      <a:fillRef idx="1">
-        <a:scrgbClr r="0" g="0" b="0"/>
-      </a:fillRef>
-      <a:effectRef idx="0">
-        <a:scrgbClr r="0" g="0" b="0"/>
-      </a:effectRef>
-      <a:fontRef idx="minor"/>
-    </dgm:style>
-  </dgm:styleLbl>
-  <dgm:styleLbl name="alignImgPlace1">
-    <dgm:scene3d>
-      <a:camera prst="orthographicFront"/>
-      <a:lightRig rig="threePt" dir="t"/>
-    </dgm:scene3d>
-    <dgm:sp3d/>
-    <dgm:txPr/>
-    <dgm:style>
-      <a:lnRef idx="2">
-        <a:scrgbClr r="0" g="0" b="0"/>
-      </a:lnRef>
-      <a:fillRef idx="1">
-        <a:scrgbClr r="0" g="0" b="0"/>
-      </a:fillRef>
-      <a:effectRef idx="0">
-        <a:scrgbClr r="0" g="0" b="0"/>
-      </a:effectRef>
-      <a:fontRef idx="minor"/>
-    </dgm:style>
-  </dgm:styleLbl>
-  <dgm:styleLbl name="bgImgPlace1">
-    <dgm:scene3d>
-      <a:camera prst="orthographicFront"/>
-      <a:lightRig rig="threePt" dir="t"/>
-    </dgm:scene3d>
-    <dgm:sp3d/>
-    <dgm:txPr/>
-    <dgm:style>
-      <a:lnRef idx="2">
-        <a:scrgbClr r="0" g="0" b="0"/>
-      </a:lnRef>
-      <a:fillRef idx="1">
-        <a:scrgbClr r="0" g="0" b="0"/>
-      </a:fillRef>
-      <a:effectRef idx="0">
-        <a:scrgbClr r="0" g="0" b="0"/>
-      </a:effectRef>
-      <a:fontRef idx="minor"/>
-    </dgm:style>
-  </dgm:styleLbl>
-  <dgm:styleLbl name="sibTrans2D1">
-    <dgm:scene3d>
-      <a:camera prst="orthographicFront"/>
-      <a:lightRig rig="threePt" dir="t"/>
-    </dgm:scene3d>
-    <dgm:sp3d/>
-    <dgm:txPr/>
-    <dgm:style>
-      <a:lnRef idx="0">
-        <a:scrgbClr r="0" g="0" b="0"/>
-      </a:lnRef>
-      <a:fillRef idx="1">
-        <a:scrgbClr r="0" g="0" b="0"/>
-      </a:fillRef>
-      <a:effectRef idx="0">
-        <a:scrgbClr r="0" g="0" b="0"/>
-      </a:effectRef>
-      <a:fontRef idx="minor">
-        <a:schemeClr val="lt1"/>
-      </a:fontRef>
-    </dgm:style>
-  </dgm:styleLbl>
-  <dgm:styleLbl name="fgSibTrans2D1">
-    <dgm:scene3d>
-      <a:camera prst="orthographicFront"/>
-      <a:lightRig rig="threePt" dir="t"/>
-    </dgm:scene3d>
-    <dgm:sp3d/>
-    <dgm:txPr/>
-    <dgm:style>
-      <a:lnRef idx="0">
-        <a:scrgbClr r="0" g="0" b="0"/>
-      </a:lnRef>
-      <a:fillRef idx="1">
-        <a:scrgbClr r="0" g="0" b="0"/>
-      </a:fillRef>
-      <a:effectRef idx="0">
-        <a:scrgbClr r="0" g="0" b="0"/>
-      </a:effectRef>
-      <a:fontRef idx="minor">
-        <a:schemeClr val="lt1"/>
-      </a:fontRef>
-    </dgm:style>
-  </dgm:styleLbl>
-  <dgm:styleLbl name="bgSibTrans2D1">
-    <dgm:scene3d>
-      <a:camera prst="orthographicFront"/>
-      <a:lightRig rig="threePt" dir="t"/>
-    </dgm:scene3d>
-    <dgm:sp3d/>
-    <dgm:txPr/>
-    <dgm:style>
-      <a:lnRef idx="0">
-        <a:scrgbClr r="0" g="0" b="0"/>
-      </a:lnRef>
-      <a:fillRef idx="1">
-        <a:scrgbClr r="0" g="0" b="0"/>
-      </a:fillRef>
-      <a:effectRef idx="0">
-        <a:scrgbClr r="0" g="0" b="0"/>
-      </a:effectRef>
-      <a:fontRef idx="minor">
-        <a:schemeClr val="lt1"/>
-      </a:fontRef>
-    </dgm:style>
-  </dgm:styleLbl>
-  <dgm:styleLbl name="sibTrans1D1">
-    <dgm:scene3d>
-      <a:camera prst="orthographicFront"/>
-      <a:lightRig rig="threePt" dir="t"/>
-    </dgm:scene3d>
-    <dgm:sp3d/>
-    <dgm:txPr/>
-    <dgm:style>
-      <a:lnRef idx="1">
-        <a:scrgbClr r="0" g="0" b="0"/>
-      </a:lnRef>
-      <a:fillRef idx="0">
-        <a:scrgbClr r="0" g="0" b="0"/>
-      </a:fillRef>
-      <a:effectRef idx="0">
-        <a:scrgbClr r="0" g="0" b="0"/>
-      </a:effectRef>
-      <a:fontRef idx="minor"/>
-    </dgm:style>
-  </dgm:styleLbl>
-  <dgm:styleLbl name="callout">
-    <dgm:scene3d>
-      <a:camera prst="orthographicFront"/>
-      <a:lightRig rig="threePt" dir="t"/>
-    </dgm:scene3d>
-    <dgm:sp3d/>
-    <dgm:txPr/>
-    <dgm:style>
-      <a:lnRef idx="2">
-        <a:scrgbClr r="0" g="0" b="0"/>
-      </a:lnRef>
-      <a:fillRef idx="1">
-        <a:scrgbClr r="0" g="0" b="0"/>
-      </a:fillRef>
-      <a:effectRef idx="0">
-        <a:scrgbClr r="0" g="0" b="0"/>
-      </a:effectRef>
-      <a:fontRef idx="minor"/>
-    </dgm:style>
-  </dgm:styleLbl>
-  <dgm:styleLbl name="asst0">
-    <dgm:scene3d>
-      <a:camera prst="orthographicFront"/>
-      <a:lightRig rig="threePt" dir="t"/>
-    </dgm:scene3d>
-    <dgm:sp3d/>
-    <dgm:txPr/>
-    <dgm:style>
-      <a:lnRef idx="2">
-        <a:scrgbClr r="0" g="0" b="0"/>
-      </a:lnRef>
-      <a:fillRef idx="1">
-        <a:scrgbClr r="0" g="0" b="0"/>
-      </a:fillRef>
-      <a:effectRef idx="0">
-        <a:scrgbClr r="0" g="0" b="0"/>
-      </a:effectRef>
-      <a:fontRef idx="minor">
-        <a:schemeClr val="lt1"/>
-      </a:fontRef>
-    </dgm:style>
-  </dgm:styleLbl>
-  <dgm:styleLbl name="asst1">
-    <dgm:scene3d>
-      <a:camera prst="orthographicFront"/>
-      <a:lightRig rig="threePt" dir="t"/>
-    </dgm:scene3d>
-    <dgm:sp3d/>
-    <dgm:txPr/>
-    <dgm:style>
-      <a:lnRef idx="2">
-        <a:scrgbClr r="0" g="0" b="0"/>
-      </a:lnRef>
-      <a:fillRef idx="1">
-        <a:scrgbClr r="0" g="0" b="0"/>
-      </a:fillRef>
-      <a:effectRef idx="0">
-        <a:scrgbClr r="0" g="0" b="0"/>
-      </a:effectRef>
-      <a:fontRef idx="minor">
-        <a:schemeClr val="lt1"/>
-      </a:fontRef>
-    </dgm:style>
-  </dgm:styleLbl>
-  <dgm:styleLbl name="asst2">
-    <dgm:scene3d>
-      <a:camera prst="orthographicFront"/>
-      <a:lightRig rig="threePt" dir="t"/>
-    </dgm:scene3d>
-    <dgm:sp3d/>
-    <dgm:txPr/>
-    <dgm:style>
-      <a:lnRef idx="2">
-        <a:scrgbClr r="0" g="0" b="0"/>
-      </a:lnRef>
-      <a:fillRef idx="1">
-        <a:scrgbClr r="0" g="0" b="0"/>
-      </a:fillRef>
-      <a:effectRef idx="0">
-        <a:scrgbClr r="0" g="0" b="0"/>
-      </a:effectRef>
-      <a:fontRef idx="minor">
-        <a:schemeClr val="lt1"/>
-      </a:fontRef>
-    </dgm:style>
-  </dgm:styleLbl>
-  <dgm:styleLbl name="asst3">
-    <dgm:scene3d>
-      <a:camera prst="orthographicFront"/>
-      <a:lightRig rig="threePt" dir="t"/>
-    </dgm:scene3d>
-    <dgm:sp3d/>
-    <dgm:txPr/>
-    <dgm:style>
-      <a:lnRef idx="2">
-        <a:scrgbClr r="0" g="0" b="0"/>
-      </a:lnRef>
-      <a:fillRef idx="1">
-        <a:scrgbClr r="0" g="0" b="0"/>
-      </a:fillRef>
-      <a:effectRef idx="0">
-        <a:scrgbClr r="0" g="0" b="0"/>
-      </a:effectRef>
-      <a:fontRef idx="minor">
-        <a:schemeClr val="lt1"/>
-      </a:fontRef>
-    </dgm:style>
-  </dgm:styleLbl>
-  <dgm:styleLbl name="asst4">
-    <dgm:scene3d>
-      <a:camera prst="orthographicFront"/>
-      <a:lightRig rig="threePt" dir="t"/>
-    </dgm:scene3d>
-    <dgm:sp3d/>
-    <dgm:txPr/>
-    <dgm:style>
-      <a:lnRef idx="2">
-        <a:scrgbClr r="0" g="0" b="0"/>
-      </a:lnRef>
-      <a:fillRef idx="1">
-        <a:scrgbClr r="0" g="0" b="0"/>
-      </a:fillRef>
-      <a:effectRef idx="0">
-        <a:scrgbClr r="0" g="0" b="0"/>
-      </a:effectRef>
-      <a:fontRef idx="minor">
-        <a:schemeClr val="lt1"/>
-      </a:fontRef>
-    </dgm:style>
-  </dgm:styleLbl>
-  <dgm:styleLbl name="parChTrans2D1">
-    <dgm:scene3d>
-      <a:camera prst="orthographicFront"/>
-      <a:lightRig rig="threePt" dir="t"/>
-    </dgm:scene3d>
-    <dgm:sp3d/>
-    <dgm:txPr/>
-    <dgm:style>
-      <a:lnRef idx="2">
-        <a:scrgbClr r="0" g="0" b="0"/>
-      </a:lnRef>
-      <a:fillRef idx="1">
-        <a:scrgbClr r="0" g="0" b="0"/>
-      </a:fillRef>
-      <a:effectRef idx="0">
-        <a:scrgbClr r="0" g="0" b="0"/>
-      </a:effectRef>
-      <a:fontRef idx="minor">
-        <a:schemeClr val="lt1"/>
-      </a:fontRef>
-    </dgm:style>
-  </dgm:styleLbl>
-  <dgm:styleLbl name="parChTrans2D2">
-    <dgm:scene3d>
-      <a:camera prst="orthographicFront"/>
-      <a:lightRig rig="threePt" dir="t"/>
-    </dgm:scene3d>
-    <dgm:sp3d/>
-    <dgm:txPr/>
-    <dgm:style>
-      <a:lnRef idx="2">
-        <a:scrgbClr r="0" g="0" b="0"/>
-      </a:lnRef>
-      <a:fillRef idx="1">
-        <a:scrgbClr r="0" g="0" b="0"/>
-      </a:fillRef>
-      <a:effectRef idx="0">
-        <a:scrgbClr r="0" g="0" b="0"/>
-      </a:effectRef>
-      <a:fontRef idx="minor">
-        <a:schemeClr val="lt1"/>
-      </a:fontRef>
-    </dgm:style>
-  </dgm:styleLbl>
-  <dgm:styleLbl name="parChTrans2D3">
-    <dgm:scene3d>
-      <a:camera prst="orthographicFront"/>
-      <a:lightRig rig="threePt" dir="t"/>
-    </dgm:scene3d>
-    <dgm:sp3d/>
-    <dgm:txPr/>
-    <dgm:style>
-      <a:lnRef idx="2">
-        <a:scrgbClr r="0" g="0" b="0"/>
-      </a:lnRef>
-      <a:fillRef idx="1">
-        <a:scrgbClr r="0" g="0" b="0"/>
-      </a:fillRef>
-      <a:effectRef idx="0">
-        <a:scrgbClr r="0" g="0" b="0"/>
-      </a:effectRef>
-      <a:fontRef idx="minor">
-        <a:schemeClr val="lt1"/>
-      </a:fontRef>
-    </dgm:style>
-  </dgm:styleLbl>
-  <dgm:styleLbl name="parChTrans2D4">
-    <dgm:scene3d>
-      <a:camera prst="orthographicFront"/>
-      <a:lightRig rig="threePt" dir="t"/>
-    </dgm:scene3d>
-    <dgm:sp3d/>
-    <dgm:txPr/>
-    <dgm:style>
-      <a:lnRef idx="2">
-        <a:scrgbClr r="0" g="0" b="0"/>
-      </a:lnRef>
-      <a:fillRef idx="1">
-        <a:scrgbClr r="0" g="0" b="0"/>
-      </a:fillRef>
-      <a:effectRef idx="0">
-        <a:scrgbClr r="0" g="0" b="0"/>
-      </a:effectRef>
-      <a:fontRef idx="minor">
-        <a:schemeClr val="lt1"/>
-      </a:fontRef>
-    </dgm:style>
-  </dgm:styleLbl>
-  <dgm:styleLbl name="parChTrans1D1">
-    <dgm:scene3d>
-      <a:camera prst="orthographicFront"/>
-      <a:lightRig rig="threePt" dir="t"/>
-    </dgm:scene3d>
-    <dgm:sp3d/>
-    <dgm:txPr/>
-    <dgm:style>
-      <a:lnRef idx="2">
-        <a:scrgbClr r="0" g="0" b="0"/>
-      </a:lnRef>
-      <a:fillRef idx="0">
-        <a:scrgbClr r="0" g="0" b="0"/>
-      </a:fillRef>
-      <a:effectRef idx="0">
-        <a:scrgbClr r="0" g="0" b="0"/>
-      </a:effectRef>
-      <a:fontRef idx="minor"/>
-    </dgm:style>
-  </dgm:styleLbl>
-  <dgm:styleLbl name="parChTrans1D2">
-    <dgm:scene3d>
-      <a:camera prst="orthographicFront"/>
-      <a:lightRig rig="threePt" dir="t"/>
-    </dgm:scene3d>
-    <dgm:sp3d/>
-    <dgm:txPr/>
-    <dgm:style>
-      <a:lnRef idx="2">
-        <a:scrgbClr r="0" g="0" b="0"/>
-      </a:lnRef>
-      <a:fillRef idx="0">
-        <a:scrgbClr r="0" g="0" b="0"/>
-      </a:fillRef>
-      <a:effectRef idx="0">
-        <a:scrgbClr r="0" g="0" b="0"/>
-      </a:effectRef>
-      <a:fontRef idx="minor"/>
-    </dgm:style>
-  </dgm:styleLbl>
-  <dgm:styleLbl name="parChTrans1D3">
-    <dgm:scene3d>
-      <a:camera prst="orthographicFront"/>
-      <a:lightRig rig="threePt" dir="t"/>
-    </dgm:scene3d>
-    <dgm:sp3d/>
-    <dgm:txPr/>
-    <dgm:style>
-      <a:lnRef idx="2">
-        <a:scrgbClr r="0" g="0" b="0"/>
-      </a:lnRef>
-      <a:fillRef idx="0">
-        <a:scrgbClr r="0" g="0" b="0"/>
-      </a:fillRef>
-      <a:effectRef idx="0">
-        <a:scrgbClr r="0" g="0" b="0"/>
-      </a:effectRef>
-      <a:fontRef idx="minor"/>
-    </dgm:style>
-  </dgm:styleLbl>
-  <dgm:styleLbl name="parChTrans1D4">
-    <dgm:scene3d>
-      <a:camera prst="orthographicFront"/>
-      <a:lightRig rig="threePt" dir="t"/>
-    </dgm:scene3d>
-    <dgm:sp3d/>
-    <dgm:txPr/>
-    <dgm:style>
-      <a:lnRef idx="2">
-        <a:scrgbClr r="0" g="0" b="0"/>
-      </a:lnRef>
-      <a:fillRef idx="0">
-        <a:scrgbClr r="0" g="0" b="0"/>
-      </a:fillRef>
-      <a:effectRef idx="0">
-        <a:scrgbClr r="0" g="0" b="0"/>
-      </a:effectRef>
-      <a:fontRef idx="minor"/>
-    </dgm:style>
-  </dgm:styleLbl>
-  <dgm:styleLbl name="fgAcc1">
-    <dgm:scene3d>
-      <a:camera prst="orthographicFront"/>
-      <a:lightRig rig="threePt" dir="t"/>
-    </dgm:scene3d>
-    <dgm:sp3d/>
-    <dgm:txPr/>
-    <dgm:style>
-      <a:lnRef idx="2">
-        <a:scrgbClr r="0" g="0" b="0"/>
-      </a:lnRef>
-      <a:fillRef idx="1">
-        <a:scrgbClr r="0" g="0" b="0"/>
-      </a:fillRef>
-      <a:effectRef idx="0">
-        <a:scrgbClr r="0" g="0" b="0"/>
-      </a:effectRef>
-      <a:fontRef idx="minor"/>
-    </dgm:style>
-  </dgm:styleLbl>
-  <dgm:styleLbl name="conFgAcc1">
-    <dgm:scene3d>
-      <a:camera prst="orthographicFront"/>
-      <a:lightRig rig="threePt" dir="t"/>
-    </dgm:scene3d>
-    <dgm:sp3d/>
-    <dgm:txPr/>
-    <dgm:style>
-      <a:lnRef idx="2">
-        <a:scrgbClr r="0" g="0" b="0"/>
-      </a:lnRef>
-      <a:fillRef idx="1">
-        <a:scrgbClr r="0" g="0" b="0"/>
-      </a:fillRef>
-      <a:effectRef idx="0">
-        <a:scrgbClr r="0" g="0" b="0"/>
-      </a:effectRef>
-      <a:fontRef idx="minor"/>
-    </dgm:style>
-  </dgm:styleLbl>
-  <dgm:styleLbl name="alignAcc1">
-    <dgm:scene3d>
-      <a:camera prst="orthographicFront"/>
-      <a:lightRig rig="threePt" dir="t"/>
-    </dgm:scene3d>
-    <dgm:sp3d/>
-    <dgm:txPr/>
-    <dgm:style>
-      <a:lnRef idx="2">
-        <a:scrgbClr r="0" g="0" b="0"/>
-      </a:lnRef>
-      <a:fillRef idx="1">
-        <a:scrgbClr r="0" g="0" b="0"/>
-      </a:fillRef>
-      <a:effectRef idx="0">
-        <a:scrgbClr r="0" g="0" b="0"/>
-      </a:effectRef>
-      <a:fontRef idx="minor"/>
-    </dgm:style>
-  </dgm:styleLbl>
-  <dgm:styleLbl name="trAlignAcc1">
-    <dgm:scene3d>
-      <a:camera prst="orthographicFront"/>
-      <a:lightRig rig="threePt" dir="t"/>
-    </dgm:scene3d>
-    <dgm:sp3d/>
-    <dgm:txPr/>
-    <dgm:style>
-      <a:lnRef idx="1">
-        <a:scrgbClr r="0" g="0" b="0"/>
-      </a:lnRef>
-      <a:fillRef idx="1">
-        <a:scrgbClr r="0" g="0" b="0"/>
-      </a:fillRef>
-      <a:effectRef idx="0">
-        <a:scrgbClr r="0" g="0" b="0"/>
-      </a:effectRef>
-      <a:fontRef idx="minor"/>
-    </dgm:style>
-  </dgm:styleLbl>
-  <dgm:styleLbl name="bgAcc1">
-    <dgm:scene3d>
-      <a:camera prst="orthographicFront"/>
-      <a:lightRig rig="threePt" dir="t"/>
-    </dgm:scene3d>
-    <dgm:sp3d/>
-    <dgm:txPr/>
-    <dgm:style>
-      <a:lnRef idx="2">
-        <a:scrgbClr r="0" g="0" b="0"/>
-      </a:lnRef>
-      <a:fillRef idx="1">
-        <a:scrgbClr r="0" g="0" b="0"/>
-      </a:fillRef>
-      <a:effectRef idx="0">
-        <a:scrgbClr r="0" g="0" b="0"/>
-      </a:effectRef>
-      <a:fontRef idx="minor"/>
-    </dgm:style>
-  </dgm:styleLbl>
-  <dgm:styleLbl name="solidFgAcc1">
-    <dgm:scene3d>
-      <a:camera prst="orthographicFront"/>
-      <a:lightRig rig="threePt" dir="t"/>
-    </dgm:scene3d>
-    <dgm:sp3d/>
-    <dgm:txPr/>
-    <dgm:style>
-      <a:lnRef idx="2">
-        <a:scrgbClr r="0" g="0" b="0"/>
-      </a:lnRef>
-      <a:fillRef idx="1">
-        <a:scrgbClr r="0" g="0" b="0"/>
-      </a:fillRef>
-      <a:effectRef idx="0">
-        <a:scrgbClr r="0" g="0" b="0"/>
-      </a:effectRef>
-      <a:fontRef idx="minor"/>
-    </dgm:style>
-  </dgm:styleLbl>
-  <dgm:styleLbl name="solidAlignAcc1">
-    <dgm:scene3d>
-      <a:camera prst="orthographicFront"/>
-      <a:lightRig rig="threePt" dir="t"/>
-    </dgm:scene3d>
-    <dgm:sp3d/>
-    <dgm:txPr/>
-    <dgm:style>
-      <a:lnRef idx="2">
-        <a:scrgbClr r="0" g="0" b="0"/>
-      </a:lnRef>
-      <a:fillRef idx="1">
-        <a:scrgbClr r="0" g="0" b="0"/>
-      </a:fillRef>
-      <a:effectRef idx="0">
-        <a:scrgbClr r="0" g="0" b="0"/>
-      </a:effectRef>
-      <a:fontRef idx="minor"/>
-    </dgm:style>
-  </dgm:styleLbl>
-  <dgm:styleLbl name="solidBgAcc1">
-    <dgm:scene3d>
-      <a:camera prst="orthographicFront"/>
-      <a:lightRig rig="threePt" dir="t"/>
-    </dgm:scene3d>
-    <dgm:sp3d/>
-    <dgm:txPr/>
-    <dgm:style>
-      <a:lnRef idx="2">
-        <a:scrgbClr r="0" g="0" b="0"/>
-      </a:lnRef>
-      <a:fillRef idx="1">
-        <a:scrgbClr r="0" g="0" b="0"/>
-      </a:fillRef>
-      <a:effectRef idx="0">
-        <a:scrgbClr r="0" g="0" b="0"/>
-      </a:effectRef>
-      <a:fontRef idx="minor"/>
-    </dgm:style>
-  </dgm:styleLbl>
-  <dgm:styleLbl name="fgAccFollowNode1">
-    <dgm:scene3d>
-      <a:camera prst="orthographicFront"/>
-      <a:lightRig rig="threePt" dir="t"/>
-    </dgm:scene3d>
-    <dgm:sp3d/>
-    <dgm:txPr/>
-    <dgm:style>
-      <a:lnRef idx="2">
-        <a:scrgbClr r="0" g="0" b="0"/>
-      </a:lnRef>
-      <a:fillRef idx="1">
-        <a:scrgbClr r="0" g="0" b="0"/>
-      </a:fillRef>
-      <a:effectRef idx="0">
-        <a:scrgbClr r="0" g="0" b="0"/>
-      </a:effectRef>
-      <a:fontRef idx="minor"/>
-    </dgm:style>
-  </dgm:styleLbl>
-  <dgm:styleLbl name="alignAccFollowNode1">
-    <dgm:scene3d>
-      <a:camera prst="orthographicFront"/>
-      <a:lightRig rig="threePt" dir="t"/>
-    </dgm:scene3d>
-    <dgm:sp3d/>
-    <dgm:txPr/>
-    <dgm:style>
-      <a:lnRef idx="2">
-        <a:scrgbClr r="0" g="0" b="0"/>
-      </a:lnRef>
-      <a:fillRef idx="1">
-        <a:scrgbClr r="0" g="0" b="0"/>
-      </a:fillRef>
-      <a:effectRef idx="0">
-        <a:scrgbClr r="0" g="0" b="0"/>
-      </a:effectRef>
-      <a:fontRef idx="minor"/>
-    </dgm:style>
-  </dgm:styleLbl>
-  <dgm:styleLbl name="bgAccFollowNode1">
-    <dgm:scene3d>
-      <a:camera prst="orthographicFront"/>
-      <a:lightRig rig="threePt" dir="t"/>
-    </dgm:scene3d>
-    <dgm:sp3d/>
-    <dgm:txPr/>
-    <dgm:style>
-      <a:lnRef idx="2">
-        <a:scrgbClr r="0" g="0" b="0"/>
-      </a:lnRef>
-      <a:fillRef idx="1">
-        <a:scrgbClr r="0" g="0" b="0"/>
-      </a:fillRef>
-      <a:effectRef idx="0">
-        <a:scrgbClr r="0" g="0" b="0"/>
-      </a:effectRef>
-      <a:fontRef idx="minor"/>
-    </dgm:style>
-  </dgm:styleLbl>
-  <dgm:styleLbl name="fgAcc0">
-    <dgm:scene3d>
-      <a:camera prst="orthographicFront"/>
-      <a:lightRig rig="threePt" dir="t"/>
-    </dgm:scene3d>
-    <dgm:sp3d/>
-    <dgm:txPr/>
-    <dgm:style>
-      <a:lnRef idx="2">
-        <a:scrgbClr r="0" g="0" b="0"/>
-      </a:lnRef>
-      <a:fillRef idx="1">
-        <a:scrgbClr r="0" g="0" b="0"/>
-      </a:fillRef>
-      <a:effectRef idx="0">
-        <a:scrgbClr r="0" g="0" b="0"/>
-      </a:effectRef>
-      <a:fontRef idx="minor"/>
-    </dgm:style>
-  </dgm:styleLbl>
-  <dgm:styleLbl name="fgAcc2">
-    <dgm:scene3d>
-      <a:camera prst="orthographicFront"/>
-      <a:lightRig rig="threePt" dir="t"/>
-    </dgm:scene3d>
-    <dgm:sp3d/>
-    <dgm:txPr/>
-    <dgm:style>
-      <a:lnRef idx="2">
-        <a:scrgbClr r="0" g="0" b="0"/>
-      </a:lnRef>
-      <a:fillRef idx="1">
-        <a:scrgbClr r="0" g="0" b="0"/>
-      </a:fillRef>
-      <a:effectRef idx="0">
-        <a:scrgbClr r="0" g="0" b="0"/>
-      </a:effectRef>
-      <a:fontRef idx="minor"/>
-    </dgm:style>
-  </dgm:styleLbl>
-  <dgm:styleLbl name="fgAcc3">
-    <dgm:scene3d>
-      <a:camera prst="orthographicFront"/>
-      <a:lightRig rig="threePt" dir="t"/>
-    </dgm:scene3d>
-    <dgm:sp3d/>
-    <dgm:txPr/>
-    <dgm:style>
-      <a:lnRef idx="2">
-        <a:scrgbClr r="0" g="0" b="0"/>
-      </a:lnRef>
-      <a:fillRef idx="1">
-        <a:scrgbClr r="0" g="0" b="0"/>
-      </a:fillRef>
-      <a:effectRef idx="0">
-        <a:scrgbClr r="0" g="0" b="0"/>
-      </a:effectRef>
-      <a:fontRef idx="minor"/>
-    </dgm:style>
-  </dgm:styleLbl>
-  <dgm:styleLbl name="fgAcc4">
-    <dgm:scene3d>
-      <a:camera prst="orthographicFront"/>
-      <a:lightRig rig="threePt" dir="t"/>
-    </dgm:scene3d>
-    <dgm:sp3d/>
-    <dgm:txPr/>
-    <dgm:style>
-      <a:lnRef idx="2">
-        <a:scrgbClr r="0" g="0" b="0"/>
-      </a:lnRef>
-      <a:fillRef idx="1">
-        <a:scrgbClr r="0" g="0" b="0"/>
-      </a:fillRef>
-      <a:effectRef idx="0">
-        <a:scrgbClr r="0" g="0" b="0"/>
-      </a:effectRef>
-      <a:fontRef idx="minor"/>
-    </dgm:style>
-  </dgm:styleLbl>
-  <dgm:styleLbl name="bgShp">
-    <dgm:scene3d>
-      <a:camera prst="orthographicFront"/>
-      <a:lightRig rig="threePt" dir="t"/>
-    </dgm:scene3d>
-    <dgm:sp3d/>
-    <dgm:txPr/>
-    <dgm:style>
-      <a:lnRef idx="0">
-        <a:scrgbClr r="0" g="0" b="0"/>
-      </a:lnRef>
-      <a:fillRef idx="1">
-        <a:scrgbClr r="0" g="0" b="0"/>
-      </a:fillRef>
-      <a:effectRef idx="0">
-        <a:scrgbClr r="0" g="0" b="0"/>
-      </a:effectRef>
-      <a:fontRef idx="minor"/>
-    </dgm:style>
-  </dgm:styleLbl>
-  <dgm:styleLbl name="dkBgShp">
-    <dgm:scene3d>
-      <a:camera prst="orthographicFront"/>
-      <a:lightRig rig="threePt" dir="t"/>
-    </dgm:scene3d>
-    <dgm:sp3d/>
-    <dgm:txPr/>
-    <dgm:style>
-      <a:lnRef idx="0">
-        <a:scrgbClr r="0" g="0" b="0"/>
-      </a:lnRef>
-      <a:fillRef idx="1">
-        <a:scrgbClr r="0" g="0" b="0"/>
-      </a:fillRef>
-      <a:effectRef idx="0">
-        <a:scrgbClr r="0" g="0" b="0"/>
-      </a:effectRef>
-      <a:fontRef idx="minor"/>
-    </dgm:style>
-  </dgm:styleLbl>
-  <dgm:styleLbl name="trBgShp">
-    <dgm:scene3d>
-      <a:camera prst="orthographicFront"/>
-      <a:lightRig rig="threePt" dir="t"/>
-    </dgm:scene3d>
-    <dgm:sp3d/>
-    <dgm:txPr/>
-    <dgm:style>
-      <a:lnRef idx="0">
-        <a:scrgbClr r="0" g="0" b="0"/>
-      </a:lnRef>
-      <a:fillRef idx="1">
-        <a:scrgbClr r="0" g="0" b="0"/>
-      </a:fillRef>
-      <a:effectRef idx="0">
-        <a:scrgbClr r="0" g="0" b="0"/>
-      </a:effectRef>
-      <a:fontRef idx="minor"/>
-    </dgm:style>
-  </dgm:styleLbl>
-  <dgm:styleLbl name="fgShp">
-    <dgm:scene3d>
-      <a:camera prst="orthographicFront"/>
-      <a:lightRig rig="threePt" dir="t"/>
-    </dgm:scene3d>
-    <dgm:sp3d/>
-    <dgm:txPr/>
-    <dgm:style>
-      <a:lnRef idx="2">
-        <a:scrgbClr r="0" g="0" b="0"/>
-      </a:lnRef>
-      <a:fillRef idx="1">
-        <a:scrgbClr r="0" g="0" b="0"/>
-      </a:fillRef>
-      <a:effectRef idx="0">
-        <a:scrgbClr r="0" g="0" b="0"/>
-      </a:effectRef>
-      <a:fontRef idx="minor"/>
-    </dgm:style>
-  </dgm:styleLbl>
-  <dgm:styleLbl name="revTx">
-    <dgm:scene3d>
-      <a:camera prst="orthographicFront"/>
-      <a:lightRig rig="threePt" dir="t"/>
-    </dgm:scene3d>
-    <dgm:sp3d/>
-    <dgm:txPr/>
-    <dgm:style>
-      <a:lnRef idx="0">
-        <a:scrgbClr r="0" g="0" b="0"/>
-      </a:lnRef>
-      <a:fillRef idx="0">
-        <a:scrgbClr r="0" g="0" b="0"/>
-      </a:fillRef>
-      <a:effectRef idx="0">
-        <a:scrgbClr r="0" g="0" b="0"/>
-      </a:effectRef>
-      <a:fontRef idx="minor"/>
-    </dgm:style>
-  </dgm:styleLbl>
-</dgm:styleDef>
 </file>
 
 <file path=ppt/handoutMasters/handoutMaster1.xml><?xml version="1.0" encoding="utf-8"?>
@@ -7265,6 +5033,72 @@
           <a:chExt cx="0" cy="0"/>
         </a:xfrm>
       </p:grpSpPr>
+      <p:pic>
+        <p:nvPicPr>
+          <p:cNvPr id="100" name="BgImage">
+            <a:extLst>
+              <a:ext uri="{FF2B5EF4-FFF2-40B4-BE49-F238E27FC236}">
+                <a16:creationId xmlns:a16="http://schemas.microsoft.com/office/drawing/2014/main" id="{A1B2C3D4-1111-2222-3333-444455556601}"/>
+              </a:ext>
+            </a:extLst>
+          </p:cNvPr>
+          <p:cNvPicPr>
+            <a:picLocks noChangeAspect="1"/>
+          </p:cNvPicPr>
+          <p:nvPr/>
+        </p:nvPicPr>
+        <p:blipFill rotWithShape="1">
+          <a:blip r:embed="rId3"/>
+          <a:srcRect t="10000"/>
+          <a:stretch/>
+        </p:blipFill>
+        <p:spPr>
+          <a:xfrm>
+            <a:off x="0" y="0"/>
+            <a:ext cx="12192000" cy="6858000"/>
+          </a:xfrm>
+          <a:prstGeom prst="rect">
+            <a:avLst/>
+          </a:prstGeom>
+        </p:spPr>
+      </p:pic>
+      <p:sp>
+        <p:nvSpPr>
+          <p:cNvPr id="101" name="DarkOverlay">
+            <a:extLst>
+              <a:ext uri="{FF2B5EF4-FFF2-40B4-BE49-F238E27FC236}">
+                <a16:creationId xmlns:a16="http://schemas.microsoft.com/office/drawing/2014/main" id="{A1B2C3D4-1111-2222-3333-444455556602}"/>
+              </a:ext>
+            </a:extLst>
+          </p:cNvPr>
+          <p:cNvSpPr/>
+          <p:nvPr/>
+        </p:nvSpPr>
+        <p:spPr>
+          <a:xfrm>
+            <a:off x="0" y="0"/>
+            <a:ext cx="12192000" cy="6858000"/>
+          </a:xfrm>
+          <a:prstGeom prst="rect">
+            <a:avLst/>
+          </a:prstGeom>
+          <a:solidFill>
+            <a:srgbClr val="000000">
+              <a:alpha val="73000"/>
+            </a:srgbClr>
+          </a:solidFill>
+          <a:ln>
+            <a:noFill/>
+          </a:ln>
+        </p:spPr>
+        <p:txBody>
+          <a:bodyPr/>
+          <a:lstStyle/>
+          <a:p>
+            <a:endParaRPr lang="es-ES"/>
+          </a:p>
+        </p:txBody>
+      </p:sp>
       <p:sp>
         <p:nvSpPr>
           <p:cNvPr id="2" name="Título 1">
@@ -7283,8 +5117,8 @@
         </p:nvSpPr>
         <p:spPr>
           <a:xfrm>
-            <a:off x="1371600" y="685800"/>
-            <a:ext cx="9601200" cy="1485900"/>
+            <a:off x="609600" y="274638"/>
+            <a:ext cx="10972800" cy="1143000"/>
           </a:xfrm>
         </p:spPr>
         <p:txBody>
@@ -7293,44 +5127,93 @@
           </a:bodyPr>
           <a:lstStyle/>
           <a:p>
-            <a:r>
-              <a:rPr lang="es-ES" noProof="1"/>
+            <a:pPr algn="l"/>
+            <a:r>
+              <a:rPr lang="es-ES" sz="3600" b="1" noProof="1">
+                <a:solidFill>
+                  <a:srgbClr val="FFFFFF"/>
+                </a:solidFill>
+              </a:rPr>
               <a:t>1. Consultas en MySQL Workbench</a:t>
             </a:r>
           </a:p>
         </p:txBody>
       </p:sp>
-      <p:graphicFrame>
-        <p:nvGraphicFramePr>
-          <p:cNvPr id="5" name="Marcador de contenido 2" descr="icono de marcador de posición del elemento gráfico SmartArt">
+      <p:sp>
+        <p:nvSpPr>
+          <p:cNvPr id="4" name="Marcador de contenido 3">
             <a:extLst>
               <a:ext uri="{FF2B5EF4-FFF2-40B4-BE49-F238E27FC236}">
-                <a16:creationId xmlns:a16="http://schemas.microsoft.com/office/drawing/2014/main" id="{E04C5C5B-F932-40FC-AD54-EE8AB0C58221}"/>
+                <a16:creationId xmlns:a16="http://schemas.microsoft.com/office/drawing/2014/main" id="{049B9B57-7DEE-25C8-25C2-00B9E9F1917A}"/>
               </a:ext>
             </a:extLst>
           </p:cNvPr>
-          <p:cNvGraphicFramePr>
-            <a:graphicFrameLocks noGrp="1"/>
-          </p:cNvGraphicFramePr>
+          <p:cNvSpPr>
+            <a:spLocks noGrp="1"/>
+          </p:cNvSpPr>
           <p:nvPr>
             <p:ph idx="1"/>
-            <p:extLst>
-              <p:ext uri="{D42A27DB-BD31-4B8C-83A1-F6EECF244321}">
-                <p14:modId xmlns:p14="http://schemas.microsoft.com/office/powerpoint/2010/main" val="2390523420"/>
-              </p:ext>
-            </p:extLst>
-          </p:nvPr>
-        </p:nvGraphicFramePr>
-        <p:xfrm>
-          <a:off x="1371600" y="2286000"/>
-          <a:ext cx="9601200" cy="3581400"/>
-        </p:xfrm>
-        <a:graphic>
-          <a:graphicData uri="http://schemas.openxmlformats.org/drawingml/2006/diagram">
-            <dgm:relIds xmlns:dgm="http://schemas.openxmlformats.org/drawingml/2006/diagram" xmlns:r="http://schemas.openxmlformats.org/officeDocument/2006/relationships" r:dm="rId3" r:lo="rId4" r:qs="rId5" r:cs="rId6"/>
-          </a:graphicData>
-        </a:graphic>
-      </p:graphicFrame>
+          </p:nvPr>
+        </p:nvSpPr>
+        <p:spPr/>
+        <p:txBody>
+          <a:bodyPr/>
+          <a:lstStyle/>
+          <a:p>
+            <a:pPr marL="0" indent="0">
+              <a:buNone/>
+            </a:pPr>
+            <a:r>
+              <a:rPr lang="es-ES" dirty="0">
+                <a:solidFill>
+                  <a:schemeClr val="bg1"/>
+                </a:solidFill>
+              </a:rPr>
+              <a:t>Realizamos las consultas sobre las tablas que vamos a usar en el dashboard y guardamos el Script con formato .sql .</a:t>
+            </a:r>
+          </a:p>
+          <a:p>
+            <a:pPr marL="0" indent="0">
+              <a:buNone/>
+            </a:pPr>
+            <a:endParaRPr lang="es-ES" dirty="0">
+              <a:solidFill>
+                <a:schemeClr val="bg1"/>
+              </a:solidFill>
+            </a:endParaRPr>
+          </a:p>
+        </p:txBody>
+      </p:sp>
+      <p:pic>
+        <p:nvPicPr>
+          <p:cNvPr id="7" name="Imagen 6">
+            <a:extLst>
+              <a:ext uri="{FF2B5EF4-FFF2-40B4-BE49-F238E27FC236}">
+                <a16:creationId xmlns:a16="http://schemas.microsoft.com/office/drawing/2014/main" id="{57101F87-08E5-370A-F85C-F3E44D1EBCCD}"/>
+              </a:ext>
+            </a:extLst>
+          </p:cNvPr>
+          <p:cNvPicPr>
+            <a:picLocks noChangeAspect="1"/>
+          </p:cNvPicPr>
+          <p:nvPr/>
+        </p:nvPicPr>
+        <p:blipFill>
+          <a:blip r:embed="rId4"/>
+          <a:stretch>
+            <a:fillRect/>
+          </a:stretch>
+        </p:blipFill>
+        <p:spPr>
+          <a:xfrm>
+            <a:off x="3781102" y="3159385"/>
+            <a:ext cx="4629796" cy="2562583"/>
+          </a:xfrm>
+          <a:prstGeom prst="rect">
+            <a:avLst/>
+          </a:prstGeom>
+        </p:spPr>
+      </p:pic>
     </p:spTree>
     <p:extLst>
       <p:ext uri="{BB962C8B-B14F-4D97-AF65-F5344CB8AC3E}">
@@ -7347,6 +5230,14 @@
 <file path=ppt/slides/slide3.xml><?xml version="1.0" encoding="utf-8"?>
 <p:sld xmlns:a="http://schemas.openxmlformats.org/drawingml/2006/main" xmlns:r="http://schemas.openxmlformats.org/officeDocument/2006/relationships" xmlns:p="http://schemas.openxmlformats.org/presentationml/2006/main">
   <p:cSld>
+    <p:bg>
+      <p:bgPr>
+        <a:solidFill>
+          <a:schemeClr val="bg2"/>
+        </a:solidFill>
+        <a:effectLst/>
+      </p:bgPr>
+    </p:bg>
     <p:spTree>
       <p:nvGrpSpPr>
         <p:cNvPr id="1" name=""/>
@@ -7361,6 +5252,72 @@
           <a:chExt cx="0" cy="0"/>
         </a:xfrm>
       </p:grpSpPr>
+      <p:pic>
+        <p:nvPicPr>
+          <p:cNvPr id="100" name="BgImage">
+            <a:extLst>
+              <a:ext uri="{FF2B5EF4-FFF2-40B4-BE49-F238E27FC236}">
+                <a16:creationId xmlns:a16="http://schemas.microsoft.com/office/drawing/2014/main" id="{B1C2D3E4-1111-2222-3333-444455556601}"/>
+              </a:ext>
+            </a:extLst>
+          </p:cNvPr>
+          <p:cNvPicPr>
+            <a:picLocks noChangeAspect="1"/>
+          </p:cNvPicPr>
+          <p:nvPr/>
+        </p:nvPicPr>
+        <p:blipFill rotWithShape="1">
+          <a:blip r:embed="rId2"/>
+          <a:srcRect t="10000"/>
+          <a:stretch/>
+        </p:blipFill>
+        <p:spPr>
+          <a:xfrm>
+            <a:off x="0" y="0"/>
+            <a:ext cx="12192000" cy="6858000"/>
+          </a:xfrm>
+          <a:prstGeom prst="rect">
+            <a:avLst/>
+          </a:prstGeom>
+        </p:spPr>
+      </p:pic>
+      <p:sp>
+        <p:nvSpPr>
+          <p:cNvPr id="101" name="DarkOverlay">
+            <a:extLst>
+              <a:ext uri="{FF2B5EF4-FFF2-40B4-BE49-F238E27FC236}">
+                <a16:creationId xmlns:a16="http://schemas.microsoft.com/office/drawing/2014/main" id="{B1C2D3E4-1111-2222-3333-444455556602}"/>
+              </a:ext>
+            </a:extLst>
+          </p:cNvPr>
+          <p:cNvSpPr/>
+          <p:nvPr/>
+        </p:nvSpPr>
+        <p:spPr>
+          <a:xfrm>
+            <a:off x="0" y="0"/>
+            <a:ext cx="12192000" cy="6858000"/>
+          </a:xfrm>
+          <a:prstGeom prst="rect">
+            <a:avLst/>
+          </a:prstGeom>
+          <a:solidFill>
+            <a:srgbClr val="000000">
+              <a:alpha val="73000"/>
+            </a:srgbClr>
+          </a:solidFill>
+          <a:ln>
+            <a:noFill/>
+          </a:ln>
+        </p:spPr>
+        <p:txBody>
+          <a:bodyPr/>
+          <a:lstStyle/>
+          <a:p>
+            <a:endParaRPr lang="es-ES"/>
+          </a:p>
+        </p:txBody>
+      </p:sp>
       <p:sp>
         <p:nvSpPr>
           <p:cNvPr id="2" name="Título 1">
@@ -7377,13 +5334,25 @@
             <p:ph type="title"/>
           </p:nvPr>
         </p:nvSpPr>
-        <p:spPr/>
-        <p:txBody>
-          <a:bodyPr/>
+        <p:spPr>
+          <a:xfrm>
+            <a:off x="609600" y="274638"/>
+            <a:ext cx="10972800" cy="1143000"/>
+          </a:xfrm>
+        </p:spPr>
+        <p:txBody>
+          <a:bodyPr rtlCol="0">
+            <a:normAutofit/>
+          </a:bodyPr>
           <a:lstStyle/>
           <a:p>
-            <a:r>
-              <a:rPr lang="es-ES" dirty="0"/>
+            <a:pPr algn="l"/>
+            <a:r>
+              <a:rPr lang="es-ES" sz="3600" b="1" noProof="1">
+                <a:solidFill>
+                  <a:srgbClr val="FFFFFF"/>
+                </a:solidFill>
+              </a:rPr>
               <a:t>2. Automatización con Python</a:t>
             </a:r>
           </a:p>
@@ -7405,12 +5374,23 @@
             <p:ph idx="1"/>
           </p:nvPr>
         </p:nvSpPr>
-        <p:spPr/>
-        <p:txBody>
-          <a:bodyPr/>
+        <p:spPr>
+          <a:xfrm>
+            <a:off x="609600" y="1600200"/>
+            <a:ext cx="10972800" cy="4800600"/>
+          </a:xfrm>
+        </p:spPr>
+        <p:txBody>
+          <a:bodyPr rtlCol="0">
+            <a:normAutofit/>
+          </a:bodyPr>
           <a:lstStyle/>
           <a:p>
-            <a:endParaRPr lang="es-ES" dirty="0"/>
+            <a:endParaRPr lang="es-ES">
+              <a:solidFill>
+                <a:srgbClr val="FFFFFF"/>
+              </a:solidFill>
+            </a:endParaRPr>
           </a:p>
         </p:txBody>
       </p:sp>
@@ -7430,6 +5410,14 @@
 <file path=ppt/slides/slide4.xml><?xml version="1.0" encoding="utf-8"?>
 <p:sld xmlns:a="http://schemas.openxmlformats.org/drawingml/2006/main" xmlns:r="http://schemas.openxmlformats.org/officeDocument/2006/relationships" xmlns:p="http://schemas.openxmlformats.org/presentationml/2006/main">
   <p:cSld>
+    <p:bg>
+      <p:bgPr>
+        <a:solidFill>
+          <a:schemeClr val="bg2"/>
+        </a:solidFill>
+        <a:effectLst/>
+      </p:bgPr>
+    </p:bg>
     <p:spTree>
       <p:nvGrpSpPr>
         <p:cNvPr id="1" name=""/>
@@ -7444,6 +5432,72 @@
           <a:chExt cx="0" cy="0"/>
         </a:xfrm>
       </p:grpSpPr>
+      <p:pic>
+        <p:nvPicPr>
+          <p:cNvPr id="100" name="BgImage">
+            <a:extLst>
+              <a:ext uri="{FF2B5EF4-FFF2-40B4-BE49-F238E27FC236}">
+                <a16:creationId xmlns:a16="http://schemas.microsoft.com/office/drawing/2014/main" id="{C1D2E3F4-1111-2222-3333-444455556601}"/>
+              </a:ext>
+            </a:extLst>
+          </p:cNvPr>
+          <p:cNvPicPr>
+            <a:picLocks noChangeAspect="1"/>
+          </p:cNvPicPr>
+          <p:nvPr/>
+        </p:nvPicPr>
+        <p:blipFill rotWithShape="1">
+          <a:blip r:embed="rId2"/>
+          <a:srcRect t="10000"/>
+          <a:stretch/>
+        </p:blipFill>
+        <p:spPr>
+          <a:xfrm>
+            <a:off x="0" y="0"/>
+            <a:ext cx="12192000" cy="6858000"/>
+          </a:xfrm>
+          <a:prstGeom prst="rect">
+            <a:avLst/>
+          </a:prstGeom>
+        </p:spPr>
+      </p:pic>
+      <p:sp>
+        <p:nvSpPr>
+          <p:cNvPr id="101" name="DarkOverlay">
+            <a:extLst>
+              <a:ext uri="{FF2B5EF4-FFF2-40B4-BE49-F238E27FC236}">
+                <a16:creationId xmlns:a16="http://schemas.microsoft.com/office/drawing/2014/main" id="{C1D2E3F4-1111-2222-3333-444455556602}"/>
+              </a:ext>
+            </a:extLst>
+          </p:cNvPr>
+          <p:cNvSpPr/>
+          <p:nvPr/>
+        </p:nvSpPr>
+        <p:spPr>
+          <a:xfrm>
+            <a:off x="0" y="0"/>
+            <a:ext cx="12192000" cy="6858000"/>
+          </a:xfrm>
+          <a:prstGeom prst="rect">
+            <a:avLst/>
+          </a:prstGeom>
+          <a:solidFill>
+            <a:srgbClr val="000000">
+              <a:alpha val="73000"/>
+            </a:srgbClr>
+          </a:solidFill>
+          <a:ln>
+            <a:noFill/>
+          </a:ln>
+        </p:spPr>
+        <p:txBody>
+          <a:bodyPr/>
+          <a:lstStyle/>
+          <a:p>
+            <a:endParaRPr lang="es-ES"/>
+          </a:p>
+        </p:txBody>
+      </p:sp>
       <p:sp>
         <p:nvSpPr>
           <p:cNvPr id="2" name="Título 1">
@@ -7460,13 +5514,25 @@
             <p:ph type="title"/>
           </p:nvPr>
         </p:nvSpPr>
-        <p:spPr/>
-        <p:txBody>
-          <a:bodyPr/>
+        <p:spPr>
+          <a:xfrm>
+            <a:off x="609600" y="274638"/>
+            <a:ext cx="10972800" cy="1143000"/>
+          </a:xfrm>
+        </p:spPr>
+        <p:txBody>
+          <a:bodyPr rtlCol="0">
+            <a:normAutofit/>
+          </a:bodyPr>
           <a:lstStyle/>
           <a:p>
-            <a:r>
-              <a:rPr lang="es-ES" dirty="0"/>
+            <a:pPr algn="l"/>
+            <a:r>
+              <a:rPr lang="es-ES" sz="3600" b="1" noProof="1">
+                <a:solidFill>
+                  <a:srgbClr val="FFFFFF"/>
+                </a:solidFill>
+              </a:rPr>
               <a:t>3. Relaciones con Power Pivot</a:t>
             </a:r>
           </a:p>
@@ -7488,12 +5554,23 @@
             <p:ph idx="1"/>
           </p:nvPr>
         </p:nvSpPr>
-        <p:spPr/>
-        <p:txBody>
-          <a:bodyPr/>
+        <p:spPr>
+          <a:xfrm>
+            <a:off x="609600" y="1600200"/>
+            <a:ext cx="10972800" cy="4800600"/>
+          </a:xfrm>
+        </p:spPr>
+        <p:txBody>
+          <a:bodyPr rtlCol="0">
+            <a:normAutofit/>
+          </a:bodyPr>
           <a:lstStyle/>
           <a:p>
-            <a:endParaRPr lang="es-ES" dirty="0"/>
+            <a:endParaRPr lang="es-ES">
+              <a:solidFill>
+                <a:srgbClr val="FFFFFF"/>
+              </a:solidFill>
+            </a:endParaRPr>
           </a:p>
         </p:txBody>
       </p:sp>
@@ -7513,6 +5590,14 @@
 <file path=ppt/slides/slide5.xml><?xml version="1.0" encoding="utf-8"?>
 <p:sld xmlns:a="http://schemas.openxmlformats.org/drawingml/2006/main" xmlns:r="http://schemas.openxmlformats.org/officeDocument/2006/relationships" xmlns:p="http://schemas.openxmlformats.org/presentationml/2006/main">
   <p:cSld>
+    <p:bg>
+      <p:bgPr>
+        <a:solidFill>
+          <a:schemeClr val="bg2"/>
+        </a:solidFill>
+        <a:effectLst/>
+      </p:bgPr>
+    </p:bg>
     <p:spTree>
       <p:nvGrpSpPr>
         <p:cNvPr id="1" name=""/>
@@ -7527,6 +5612,72 @@
           <a:chExt cx="0" cy="0"/>
         </a:xfrm>
       </p:grpSpPr>
+      <p:pic>
+        <p:nvPicPr>
+          <p:cNvPr id="100" name="BgImage">
+            <a:extLst>
+              <a:ext uri="{FF2B5EF4-FFF2-40B4-BE49-F238E27FC236}">
+                <a16:creationId xmlns:a16="http://schemas.microsoft.com/office/drawing/2014/main" id="{D1E2F3A4-1111-2222-3333-444455556601}"/>
+              </a:ext>
+            </a:extLst>
+          </p:cNvPr>
+          <p:cNvPicPr>
+            <a:picLocks noChangeAspect="1"/>
+          </p:cNvPicPr>
+          <p:nvPr/>
+        </p:nvPicPr>
+        <p:blipFill rotWithShape="1">
+          <a:blip r:embed="rId2"/>
+          <a:srcRect t="10000"/>
+          <a:stretch/>
+        </p:blipFill>
+        <p:spPr>
+          <a:xfrm>
+            <a:off x="0" y="0"/>
+            <a:ext cx="12192000" cy="6858000"/>
+          </a:xfrm>
+          <a:prstGeom prst="rect">
+            <a:avLst/>
+          </a:prstGeom>
+        </p:spPr>
+      </p:pic>
+      <p:sp>
+        <p:nvSpPr>
+          <p:cNvPr id="101" name="DarkOverlay">
+            <a:extLst>
+              <a:ext uri="{FF2B5EF4-FFF2-40B4-BE49-F238E27FC236}">
+                <a16:creationId xmlns:a16="http://schemas.microsoft.com/office/drawing/2014/main" id="{D1E2F3A4-1111-2222-3333-444455556602}"/>
+              </a:ext>
+            </a:extLst>
+          </p:cNvPr>
+          <p:cNvSpPr/>
+          <p:nvPr/>
+        </p:nvSpPr>
+        <p:spPr>
+          <a:xfrm>
+            <a:off x="0" y="0"/>
+            <a:ext cx="12192000" cy="6858000"/>
+          </a:xfrm>
+          <a:prstGeom prst="rect">
+            <a:avLst/>
+          </a:prstGeom>
+          <a:solidFill>
+            <a:srgbClr val="000000">
+              <a:alpha val="73000"/>
+            </a:srgbClr>
+          </a:solidFill>
+          <a:ln>
+            <a:noFill/>
+          </a:ln>
+        </p:spPr>
+        <p:txBody>
+          <a:bodyPr/>
+          <a:lstStyle/>
+          <a:p>
+            <a:endParaRPr lang="es-ES"/>
+          </a:p>
+        </p:txBody>
+      </p:sp>
       <p:sp>
         <p:nvSpPr>
           <p:cNvPr id="2" name="Título 1">
@@ -7543,13 +5694,25 @@
             <p:ph type="title"/>
           </p:nvPr>
         </p:nvSpPr>
-        <p:spPr/>
-        <p:txBody>
-          <a:bodyPr/>
+        <p:spPr>
+          <a:xfrm>
+            <a:off x="609600" y="274638"/>
+            <a:ext cx="10972800" cy="1143000"/>
+          </a:xfrm>
+        </p:spPr>
+        <p:txBody>
+          <a:bodyPr rtlCol="0">
+            <a:normAutofit/>
+          </a:bodyPr>
           <a:lstStyle/>
           <a:p>
-            <a:r>
-              <a:rPr lang="es-ES" dirty="0"/>
+            <a:pPr algn="l"/>
+            <a:r>
+              <a:rPr lang="es-ES" sz="3600" b="1" noProof="1">
+                <a:solidFill>
+                  <a:srgbClr val="FFFFFF"/>
+                </a:solidFill>
+              </a:rPr>
               <a:t>4. Dashboard en Excel</a:t>
             </a:r>
           </a:p>
@@ -7571,12 +5734,23 @@
             <p:ph idx="1"/>
           </p:nvPr>
         </p:nvSpPr>
-        <p:spPr/>
-        <p:txBody>
-          <a:bodyPr/>
+        <p:spPr>
+          <a:xfrm>
+            <a:off x="609600" y="1600200"/>
+            <a:ext cx="10972800" cy="4800600"/>
+          </a:xfrm>
+        </p:spPr>
+        <p:txBody>
+          <a:bodyPr rtlCol="0">
+            <a:normAutofit/>
+          </a:bodyPr>
           <a:lstStyle/>
           <a:p>
-            <a:endParaRPr lang="es-ES" dirty="0"/>
+            <a:endParaRPr lang="es-ES">
+              <a:solidFill>
+                <a:srgbClr val="FFFFFF"/>
+              </a:solidFill>
+            </a:endParaRPr>
           </a:p>
         </p:txBody>
       </p:sp>
@@ -8408,6 +6582,23 @@
 </file>
 
 <file path=customXml/item1.xml><?xml version="1.0" encoding="utf-8"?>
+<?mso-contentType ?>
+<FormTemplates xmlns="http://schemas.microsoft.com/sharepoint/v3/contenttype/forms">
+  <Display>DocumentLibraryForm</Display>
+  <Edit>DocumentLibraryForm</Edit>
+  <New>DocumentLibraryForm</New>
+</FormTemplates>
+</file>
+
+<file path=customXml/item2.xml><?xml version="1.0" encoding="utf-8"?>
+<p:properties xmlns:p="http://schemas.microsoft.com/office/2006/metadata/properties" xmlns:xsi="http://www.w3.org/2001/XMLSchema-instance" xmlns:pc="http://schemas.microsoft.com/office/infopath/2007/PartnerControls">
+  <documentManagement>
+    <MediaServiceKeyPoints xmlns="71af3243-3dd4-4a8d-8c0d-dd76da1f02a5" xsi:nil="true"/>
+  </documentManagement>
+</p:properties>
+</file>
+
+<file path=customXml/item3.xml><?xml version="1.0" encoding="utf-8"?>
 <ct:contentTypeSchema xmlns:ct="http://schemas.microsoft.com/office/2006/metadata/contentType" xmlns:ma="http://schemas.microsoft.com/office/2006/metadata/properties/metaAttributes" ct:_="" ma:_="" ma:contentTypeName="Document" ma:contentTypeID="0x01010079F111ED35F8CC479449609E8A0923A6" ma:contentTypeVersion="11" ma:contentTypeDescription="Create a new document." ma:contentTypeScope="" ma:versionID="9677210f24a1be23c92c90fd886aa0aa">
   <xsd:schema xmlns:xsd="http://www.w3.org/2001/XMLSchema" xmlns:xs="http://www.w3.org/2001/XMLSchema" xmlns:p="http://schemas.microsoft.com/office/2006/metadata/properties" xmlns:ns2="71af3243-3dd4-4a8d-8c0d-dd76da1f02a5" xmlns:ns3="16c05727-aa75-4e4a-9b5f-8a80a1165891" targetNamespace="http://schemas.microsoft.com/office/2006/metadata/properties" ma:root="true" ma:fieldsID="60e05723c5c1908df1a1a4ebf11d344e" ns2:_="" ns3:_="">
     <xsd:import namespace="71af3243-3dd4-4a8d-8c0d-dd76da1f02a5"/>
@@ -8618,24 +6809,25 @@
 </ct:contentTypeSchema>
 </file>
 
-<file path=customXml/item2.xml><?xml version="1.0" encoding="utf-8"?>
-<p:properties xmlns:p="http://schemas.microsoft.com/office/2006/metadata/properties" xmlns:xsi="http://www.w3.org/2001/XMLSchema-instance" xmlns:pc="http://schemas.microsoft.com/office/infopath/2007/PartnerControls">
-  <documentManagement>
-    <MediaServiceKeyPoints xmlns="71af3243-3dd4-4a8d-8c0d-dd76da1f02a5" xsi:nil="true"/>
-  </documentManagement>
-</p:properties>
+<file path=customXml/itemProps1.xml><?xml version="1.0" encoding="utf-8"?>
+<ds:datastoreItem xmlns:ds="http://schemas.openxmlformats.org/officeDocument/2006/customXml" ds:itemID="{8C45FB24-BEC6-4D44-888B-84AEBBA2DC09}">
+  <ds:schemaRefs>
+    <ds:schemaRef ds:uri="http://schemas.microsoft.com/sharepoint/v3/contenttype/forms"/>
+  </ds:schemaRefs>
+</ds:datastoreItem>
 </file>
 
-<file path=customXml/item3.xml><?xml version="1.0" encoding="utf-8"?>
-<?mso-contentType ?>
-<FormTemplates xmlns="http://schemas.microsoft.com/sharepoint/v3/contenttype/forms">
-  <Display>DocumentLibraryForm</Display>
-  <Edit>DocumentLibraryForm</Edit>
-  <New>DocumentLibraryForm</New>
-</FormTemplates>
+<file path=customXml/itemProps2.xml><?xml version="1.0" encoding="utf-8"?>
+<ds:datastoreItem xmlns:ds="http://schemas.openxmlformats.org/officeDocument/2006/customXml" ds:itemID="{3FD9A38F-9A2C-42E5-9013-4C4B1FFCB4F6}">
+  <ds:schemaRefs>
+    <ds:schemaRef ds:uri="http://schemas.microsoft.com/office/2006/metadata/properties"/>
+    <ds:schemaRef ds:uri="http://schemas.microsoft.com/office/infopath/2007/PartnerControls"/>
+    <ds:schemaRef ds:uri="71af3243-3dd4-4a8d-8c0d-dd76da1f02a5"/>
+  </ds:schemaRefs>
+</ds:datastoreItem>
 </file>
 
-<file path=customXml/itemProps1.xml><?xml version="1.0" encoding="utf-8"?>
+<file path=customXml/itemProps3.xml><?xml version="1.0" encoding="utf-8"?>
 <ds:datastoreItem xmlns:ds="http://schemas.openxmlformats.org/officeDocument/2006/customXml" ds:itemID="{07ECF6D8-9EA4-45A1-AFEB-B7C326AF0859}">
   <ds:schemaRefs>
     <ds:schemaRef ds:uri="http://schemas.microsoft.com/office/2006/metadata/contentType"/>
@@ -8652,22 +6844,4 @@
     <ds:schemaRef ds:uri="http://schemas.microsoft.com/internal/obd"/>
   </ds:schemaRefs>
 </ds:datastoreItem>
-</file>
-
-<file path=customXml/itemProps2.xml><?xml version="1.0" encoding="utf-8"?>
-<ds:datastoreItem xmlns:ds="http://schemas.openxmlformats.org/officeDocument/2006/customXml" ds:itemID="{3FD9A38F-9A2C-42E5-9013-4C4B1FFCB4F6}">
-  <ds:schemaRefs>
-    <ds:schemaRef ds:uri="http://schemas.microsoft.com/office/2006/metadata/properties"/>
-    <ds:schemaRef ds:uri="http://schemas.microsoft.com/office/infopath/2007/PartnerControls"/>
-    <ds:schemaRef ds:uri="71af3243-3dd4-4a8d-8c0d-dd76da1f02a5"/>
-  </ds:schemaRefs>
-</ds:datastoreItem>
-</file>
-
-<file path=customXml/itemProps3.xml><?xml version="1.0" encoding="utf-8"?>
-<ds:datastoreItem xmlns:ds="http://schemas.openxmlformats.org/officeDocument/2006/customXml" ds:itemID="{8C45FB24-BEC6-4D44-888B-84AEBBA2DC09}">
-  <ds:schemaRefs>
-    <ds:schemaRef ds:uri="http://schemas.microsoft.com/sharepoint/v3/contenttype/forms"/>
-  </ds:schemaRefs>
-</ds:datastoreItem>
 </file>
</xml_diff>